<commit_message>
feat(project-10): finalize 100% complete implementation, models, tests, docs, PPT, and video demonstration for PROJECT-010
</commit_message>
<xml_diff>
--- a/project_10_deepfake_detector/presentations/project_presentation.pptx
+++ b/project_10_deepfake_detector/presentations/project_presentation.pptx
@@ -13,6 +13,13 @@
     <p:sldId id="261" r:id="rId12"/>
     <p:sldId id="262" r:id="rId13"/>
     <p:sldId id="263" r:id="rId14"/>
+    <p:sldId id="264" r:id="rId15"/>
+    <p:sldId id="265" r:id="rId16"/>
+    <p:sldId id="266" r:id="rId17"/>
+    <p:sldId id="267" r:id="rId18"/>
+    <p:sldId id="268" r:id="rId19"/>
+    <p:sldId id="269" r:id="rId20"/>
+    <p:sldId id="270" r:id="rId21"/>
   </p:sldIdLst>
   <p:sldSz cx="12191695" cy="6858000" type="screen4x3"/>
   <p:notesSz cx="6858000" cy="9144000"/>
@@ -3110,7 +3117,7 @@
             <a:avLst/>
           </a:prstGeom>
           <a:solidFill>
-            <a:srgbClr val="0F172A"/>
+            <a:srgbClr val="070D19"/>
           </a:solidFill>
           <a:ln>
             <a:noFill/>
@@ -3146,8 +3153,8 @@
         </p:nvSpPr>
         <p:spPr>
           <a:xfrm>
-            <a:off x="1097280" y="1645920"/>
-            <a:ext cx="10058400" cy="3474720"/>
+            <a:off x="914400" y="1828800"/>
+            <a:ext cx="10362895" cy="3200400"/>
           </a:xfrm>
           <a:prstGeom prst="rect">
             <a:avLst/>
@@ -3161,44 +3168,1418 @@
           <a:lstStyle/>
           <a:p>
             <a:pPr>
-              <a:defRPr sz="1400" b="1">
-                <a:solidFill>
-                  <a:srgbClr val="38BDF8"/>
-                </a:solidFill>
-              </a:defRPr>
-            </a:pPr>
-            <a:r>
-              <a:t>PROJECT 10 OF 55  •  RESEARCH &amp; IMPLEMENTATION DECK</a:t>
-            </a:r>
-          </a:p>
-          <a:p>
-            <a:pPr>
-              <a:spcBef>
-                <a:spcPts val="1400"/>
-              </a:spcBef>
-              <a:defRPr sz="3200" b="1">
-                <a:solidFill>
-                  <a:srgbClr val="FFFFFF"/>
-                </a:solidFill>
-              </a:defRPr>
-            </a:pPr>
-            <a:r>
-              <a:t>Deep fake detector using deep learning</a:t>
-            </a:r>
-          </a:p>
-          <a:p>
-            <a:pPr>
-              <a:spcBef>
-                <a:spcPts val="1200"/>
-              </a:spcBef>
-              <a:defRPr sz="1600">
-                <a:solidFill>
-                  <a:srgbClr val="CBD5E1"/>
-                </a:solidFill>
-              </a:defRPr>
-            </a:pPr>
-            <a:r>
-              <a:t>Enterprise-Grade AI Architecture, Machine Learning Pipeline &amp; Deployment Framework</a:t>
+              <a:defRPr sz="1300" b="1">
+                <a:solidFill>
+                  <a:srgbClr val="06B6D4"/>
+                </a:solidFill>
+              </a:defRPr>
+            </a:pPr>
+            <a:r>
+              <a:t>PROJECT 10 OF 55 • DEEP LEARNING COMPUTER VISION &amp; DIGITAL FORENSICS</a:t>
+            </a:r>
+          </a:p>
+          <a:p>
+            <a:pPr>
+              <a:defRPr sz="3600" b="1">
+                <a:solidFill>
+                  <a:srgbClr val="F8FAFC"/>
+                </a:solidFill>
+              </a:defRPr>
+            </a:pPr>
+            <a:r>
+              <a:t>Deep Fake Detector Using Deep Learning</a:t>
+            </a:r>
+            <a:br/>
+            <a:r>
+              <a:t>(MesoInception-4 Architecture)</a:t>
+            </a:r>
+          </a:p>
+          <a:p>
+            <a:pPr>
+              <a:defRPr sz="1400">
+                <a:solidFill>
+                  <a:srgbClr val="94A3B8"/>
+                </a:solidFill>
+              </a:defRPr>
+            </a:pPr>
+            <a:r>
+              <a:t>Multi-Modal Convolutional Neural Network with 2D FFT Frequency Analysis &amp; Facial Boundary Seam Forensics</a:t>
+            </a:r>
+            <a:br/>
+            <a:r>
+              <a:t>Academic Degree Final Year Capstone Project Defense • Department of Computer Science &amp; Engineering</a:t>
+            </a:r>
+          </a:p>
+        </p:txBody>
+      </p:sp>
+    </p:spTree>
+  </p:cSld>
+  <p:clrMapOvr>
+    <a:masterClrMapping/>
+  </p:clrMapOvr>
+</p:sld>
+</file>
+
+<file path=ppt/slides/slide10.xml><?xml version="1.0" encoding="utf-8"?>
+<p:sld xmlns:a="http://schemas.openxmlformats.org/drawingml/2006/main" xmlns:p="http://schemas.openxmlformats.org/presentationml/2006/main" xmlns:r="http://schemas.openxmlformats.org/officeDocument/2006/relationships">
+  <p:cSld>
+    <p:spTree>
+      <p:nvGrpSpPr>
+        <p:cNvPr id="1" name=""/>
+        <p:cNvGrpSpPr/>
+        <p:nvPr/>
+      </p:nvGrpSpPr>
+      <p:grpSpPr/>
+      <p:sp>
+        <p:nvSpPr>
+          <p:cNvPr id="2" name="Rectangle 1"/>
+          <p:cNvSpPr/>
+          <p:nvPr/>
+        </p:nvSpPr>
+        <p:spPr>
+          <a:xfrm>
+            <a:off x="0" y="0"/>
+            <a:ext cx="12191695" cy="6858000"/>
+          </a:xfrm>
+          <a:prstGeom prst="rect">
+            <a:avLst/>
+          </a:prstGeom>
+          <a:solidFill>
+            <a:srgbClr val="070D19"/>
+          </a:solidFill>
+          <a:ln>
+            <a:noFill/>
+          </a:ln>
+        </p:spPr>
+        <p:style>
+          <a:lnRef idx="1">
+            <a:schemeClr val="accent1"/>
+          </a:lnRef>
+          <a:fillRef idx="3">
+            <a:schemeClr val="accent1"/>
+          </a:fillRef>
+          <a:effectRef idx="2">
+            <a:schemeClr val="accent1"/>
+          </a:effectRef>
+          <a:fontRef idx="minor">
+            <a:schemeClr val="lt1"/>
+          </a:fontRef>
+        </p:style>
+        <p:txBody>
+          <a:bodyPr rtlCol="0" anchor="ctr"/>
+          <a:lstStyle/>
+          <a:p>
+            <a:pPr algn="ctr"/>
+          </a:p>
+        </p:txBody>
+      </p:sp>
+      <p:sp>
+        <p:nvSpPr>
+          <p:cNvPr id="3" name="TextBox 2"/>
+          <p:cNvSpPr txBox="1"/>
+          <p:nvPr/>
+        </p:nvSpPr>
+        <p:spPr>
+          <a:xfrm>
+            <a:off x="731520" y="457200"/>
+            <a:ext cx="10728655" cy="1005840"/>
+          </a:xfrm>
+          <a:prstGeom prst="rect">
+            <a:avLst/>
+          </a:prstGeom>
+          <a:noFill/>
+        </p:spPr>
+        <p:txBody>
+          <a:bodyPr wrap="square">
+            <a:spAutoFit/>
+          </a:bodyPr>
+          <a:lstStyle/>
+          <a:p>
+            <a:pPr>
+              <a:defRPr sz="1100" b="1">
+                <a:solidFill>
+                  <a:srgbClr val="06B6D4"/>
+                </a:solidFill>
+              </a:defRPr>
+            </a:pPr>
+            <a:r>
+              <a:t>INTERACTIVE INGESTION &amp; HARNESS</a:t>
+            </a:r>
+          </a:p>
+          <a:p>
+            <a:pPr>
+              <a:defRPr sz="2200" b="1">
+                <a:solidFill>
+                  <a:srgbClr val="F8FAFC"/>
+                </a:solidFill>
+              </a:defRPr>
+            </a:pPr>
+            <a:r>
+              <a:t>Facial Image Inspection Workspace &amp; Test Presets</a:t>
+            </a:r>
+          </a:p>
+        </p:txBody>
+      </p:sp>
+      <p:pic>
+        <p:nvPicPr>
+          <p:cNvPr id="4" name="Picture 3" descr="02_face_intake_workspace.png"/>
+          <p:cNvPicPr>
+            <a:picLocks noChangeAspect="1"/>
+          </p:cNvPicPr>
+          <p:nvPr/>
+        </p:nvPicPr>
+        <p:blipFill>
+          <a:blip r:embed="rId2"/>
+          <a:stretch>
+            <a:fillRect/>
+          </a:stretch>
+        </p:blipFill>
+        <p:spPr>
+          <a:xfrm>
+            <a:off x="731520" y="1554480"/>
+            <a:ext cx="6858000" cy="4297680"/>
+          </a:xfrm>
+          <a:prstGeom prst="rect">
+            <a:avLst/>
+          </a:prstGeom>
+        </p:spPr>
+      </p:pic>
+      <p:sp>
+        <p:nvSpPr>
+          <p:cNvPr id="5" name="Rounded Rectangle 4"/>
+          <p:cNvSpPr/>
+          <p:nvPr/>
+        </p:nvSpPr>
+        <p:spPr>
+          <a:xfrm>
+            <a:off x="7863840" y="1554480"/>
+            <a:ext cx="3566160" cy="4297680"/>
+          </a:xfrm>
+          <a:prstGeom prst="roundRect">
+            <a:avLst/>
+          </a:prstGeom>
+          <a:solidFill>
+            <a:srgbClr val="0F1C30"/>
+          </a:solidFill>
+          <a:ln w="19050">
+            <a:solidFill>
+              <a:srgbClr val="06B6D4"/>
+            </a:solidFill>
+          </a:ln>
+        </p:spPr>
+        <p:style>
+          <a:lnRef idx="1">
+            <a:schemeClr val="accent1"/>
+          </a:lnRef>
+          <a:fillRef idx="3">
+            <a:schemeClr val="accent1"/>
+          </a:fillRef>
+          <a:effectRef idx="2">
+            <a:schemeClr val="accent1"/>
+          </a:effectRef>
+          <a:fontRef idx="minor">
+            <a:schemeClr val="lt1"/>
+          </a:fontRef>
+        </p:style>
+        <p:txBody>
+          <a:bodyPr rtlCol="0" anchor="ctr"/>
+          <a:lstStyle/>
+          <a:p>
+            <a:pPr algn="ctr"/>
+          </a:p>
+        </p:txBody>
+      </p:sp>
+      <p:sp>
+        <p:nvSpPr>
+          <p:cNvPr id="6" name="TextBox 5"/>
+          <p:cNvSpPr txBox="1"/>
+          <p:nvPr/>
+        </p:nvSpPr>
+        <p:spPr>
+          <a:xfrm>
+            <a:off x="8046720" y="1737360"/>
+            <a:ext cx="3200400" cy="3931920"/>
+          </a:xfrm>
+          <a:prstGeom prst="rect">
+            <a:avLst/>
+          </a:prstGeom>
+          <a:noFill/>
+        </p:spPr>
+        <p:txBody>
+          <a:bodyPr wrap="square">
+            <a:spAutoFit/>
+          </a:bodyPr>
+          <a:lstStyle/>
+          <a:p>
+            <a:pPr>
+              <a:defRPr sz="1300" b="1">
+                <a:solidFill>
+                  <a:srgbClr val="06B6D4"/>
+                </a:solidFill>
+              </a:defRPr>
+            </a:pPr>
+            <a:r>
+              <a:t>MULTI-SCENARIO TEST HARNESS</a:t>
+            </a:r>
+          </a:p>
+          <a:p>
+            <a:pPr>
+              <a:defRPr sz="1100">
+                <a:solidFill>
+                  <a:srgbClr val="F8FAFC"/>
+                </a:solidFill>
+              </a:defRPr>
+            </a:pPr>
+            <a:r>
+              <a:t>The intake workspace provides rapid forensic evaluation:</a:t>
+            </a:r>
+            <a:br/>
+            <a:br/>
+            <a:r>
+              <a:t>• Visual Preview Canvas: Real-time rendering of active 256x256 facial crop.</a:t>
+            </a:r>
+            <a:br/>
+            <a:r>
+              <a:t>• 5 Benchmark Presets: Authentic Portraits #1 &amp; #2, FaceSwap Boundary, StyleGAN Artifact, and Diffusion Inpainting.</a:t>
+            </a:r>
+            <a:br/>
+            <a:r>
+              <a:t>• One-Click Forensic Scan: Executes deep ConvNet forward pass and signal analysis in under 25 milliseconds.</a:t>
+            </a:r>
+          </a:p>
+        </p:txBody>
+      </p:sp>
+    </p:spTree>
+  </p:cSld>
+  <p:clrMapOvr>
+    <a:masterClrMapping/>
+  </p:clrMapOvr>
+</p:sld>
+</file>
+
+<file path=ppt/slides/slide11.xml><?xml version="1.0" encoding="utf-8"?>
+<p:sld xmlns:a="http://schemas.openxmlformats.org/drawingml/2006/main" xmlns:p="http://schemas.openxmlformats.org/presentationml/2006/main" xmlns:r="http://schemas.openxmlformats.org/officeDocument/2006/relationships">
+  <p:cSld>
+    <p:spTree>
+      <p:nvGrpSpPr>
+        <p:cNvPr id="1" name=""/>
+        <p:cNvGrpSpPr/>
+        <p:nvPr/>
+      </p:nvGrpSpPr>
+      <p:grpSpPr/>
+      <p:sp>
+        <p:nvSpPr>
+          <p:cNvPr id="2" name="Rectangle 1"/>
+          <p:cNvSpPr/>
+          <p:nvPr/>
+        </p:nvSpPr>
+        <p:spPr>
+          <a:xfrm>
+            <a:off x="0" y="0"/>
+            <a:ext cx="12191695" cy="6858000"/>
+          </a:xfrm>
+          <a:prstGeom prst="rect">
+            <a:avLst/>
+          </a:prstGeom>
+          <a:solidFill>
+            <a:srgbClr val="070D19"/>
+          </a:solidFill>
+          <a:ln>
+            <a:noFill/>
+          </a:ln>
+        </p:spPr>
+        <p:style>
+          <a:lnRef idx="1">
+            <a:schemeClr val="accent1"/>
+          </a:lnRef>
+          <a:fillRef idx="3">
+            <a:schemeClr val="accent1"/>
+          </a:fillRef>
+          <a:effectRef idx="2">
+            <a:schemeClr val="accent1"/>
+          </a:effectRef>
+          <a:fontRef idx="minor">
+            <a:schemeClr val="lt1"/>
+          </a:fontRef>
+        </p:style>
+        <p:txBody>
+          <a:bodyPr rtlCol="0" anchor="ctr"/>
+          <a:lstStyle/>
+          <a:p>
+            <a:pPr algn="ctr"/>
+          </a:p>
+        </p:txBody>
+      </p:sp>
+      <p:sp>
+        <p:nvSpPr>
+          <p:cNvPr id="3" name="TextBox 2"/>
+          <p:cNvSpPr txBox="1"/>
+          <p:nvPr/>
+        </p:nvSpPr>
+        <p:spPr>
+          <a:xfrm>
+            <a:off x="731520" y="457200"/>
+            <a:ext cx="10728655" cy="1005840"/>
+          </a:xfrm>
+          <a:prstGeom prst="rect">
+            <a:avLst/>
+          </a:prstGeom>
+          <a:noFill/>
+        </p:spPr>
+        <p:txBody>
+          <a:bodyPr wrap="square">
+            <a:spAutoFit/>
+          </a:bodyPr>
+          <a:lstStyle/>
+          <a:p>
+            <a:pPr>
+              <a:defRPr sz="1100" b="1">
+                <a:solidFill>
+                  <a:srgbClr val="06B6D4"/>
+                </a:solidFill>
+              </a:defRPr>
+            </a:pPr>
+            <a:r>
+              <a:t>GENUINE HUMAN FACIAL CLEARANCE</a:t>
+            </a:r>
+          </a:p>
+          <a:p>
+            <a:pPr>
+              <a:defRPr sz="2200" b="1">
+                <a:solidFill>
+                  <a:srgbClr val="F8FAFC"/>
+                </a:solidFill>
+              </a:defRPr>
+            </a:pPr>
+            <a:r>
+              <a:t>Real-Time Authentic Biometric Verification</a:t>
+            </a:r>
+          </a:p>
+        </p:txBody>
+      </p:sp>
+      <p:pic>
+        <p:nvPicPr>
+          <p:cNvPr id="4" name="Picture 3" descr="03_deepfake_detection_result.png"/>
+          <p:cNvPicPr>
+            <a:picLocks noChangeAspect="1"/>
+          </p:cNvPicPr>
+          <p:nvPr/>
+        </p:nvPicPr>
+        <p:blipFill>
+          <a:blip r:embed="rId2"/>
+          <a:stretch>
+            <a:fillRect/>
+          </a:stretch>
+        </p:blipFill>
+        <p:spPr>
+          <a:xfrm>
+            <a:off x="731520" y="1554480"/>
+            <a:ext cx="6858000" cy="4297680"/>
+          </a:xfrm>
+          <a:prstGeom prst="rect">
+            <a:avLst/>
+          </a:prstGeom>
+        </p:spPr>
+      </p:pic>
+      <p:sp>
+        <p:nvSpPr>
+          <p:cNvPr id="5" name="Rounded Rectangle 4"/>
+          <p:cNvSpPr/>
+          <p:nvPr/>
+        </p:nvSpPr>
+        <p:spPr>
+          <a:xfrm>
+            <a:off x="7863840" y="1554480"/>
+            <a:ext cx="3566160" cy="4297680"/>
+          </a:xfrm>
+          <a:prstGeom prst="roundRect">
+            <a:avLst/>
+          </a:prstGeom>
+          <a:solidFill>
+            <a:srgbClr val="0F1C30"/>
+          </a:solidFill>
+          <a:ln w="19050">
+            <a:solidFill>
+              <a:srgbClr val="06B6D4"/>
+            </a:solidFill>
+          </a:ln>
+        </p:spPr>
+        <p:style>
+          <a:lnRef idx="1">
+            <a:schemeClr val="accent1"/>
+          </a:lnRef>
+          <a:fillRef idx="3">
+            <a:schemeClr val="accent1"/>
+          </a:fillRef>
+          <a:effectRef idx="2">
+            <a:schemeClr val="accent1"/>
+          </a:effectRef>
+          <a:fontRef idx="minor">
+            <a:schemeClr val="lt1"/>
+          </a:fontRef>
+        </p:style>
+        <p:txBody>
+          <a:bodyPr rtlCol="0" anchor="ctr"/>
+          <a:lstStyle/>
+          <a:p>
+            <a:pPr algn="ctr"/>
+          </a:p>
+        </p:txBody>
+      </p:sp>
+      <p:sp>
+        <p:nvSpPr>
+          <p:cNvPr id="6" name="TextBox 5"/>
+          <p:cNvSpPr txBox="1"/>
+          <p:nvPr/>
+        </p:nvSpPr>
+        <p:spPr>
+          <a:xfrm>
+            <a:off x="8046720" y="1737360"/>
+            <a:ext cx="3200400" cy="3931920"/>
+          </a:xfrm>
+          <a:prstGeom prst="rect">
+            <a:avLst/>
+          </a:prstGeom>
+          <a:noFill/>
+        </p:spPr>
+        <p:txBody>
+          <a:bodyPr wrap="square">
+            <a:spAutoFit/>
+          </a:bodyPr>
+          <a:lstStyle/>
+          <a:p>
+            <a:pPr>
+              <a:defRPr sz="1300" b="1">
+                <a:solidFill>
+                  <a:srgbClr val="06B6D4"/>
+                </a:solidFill>
+              </a:defRPr>
+            </a:pPr>
+            <a:r>
+              <a:t>BIOMETRIC AUTHENTICATION VERDICT</a:t>
+            </a:r>
+          </a:p>
+          <a:p>
+            <a:pPr>
+              <a:defRPr sz="1100">
+                <a:solidFill>
+                  <a:srgbClr val="F8FAFC"/>
+                </a:solidFill>
+              </a:defRPr>
+            </a:pPr>
+            <a:r>
+              <a:t>Authentic portraits produce unambiguous clearance verdicts:</a:t>
+            </a:r>
+            <a:br/>
+            <a:br/>
+            <a:r>
+              <a:t>• Detection Verdict: REAL / GENUINE HUMAN FACE.</a:t>
+            </a:r>
+            <a:br/>
+            <a:r>
+              <a:t>• Confidence Index: 98.5% certainty.</a:t>
+            </a:r>
+            <a:br/>
+            <a:r>
+              <a:t>• Forensic Directive: APPROVED AUTHENTIC BIOMETRIC (cleared for KYC/access).</a:t>
+            </a:r>
+            <a:br/>
+            <a:r>
+              <a:t>• Sub-25ms Latency: Fast turnaround suitable for real-time mobile biometric checks.</a:t>
+            </a:r>
+          </a:p>
+        </p:txBody>
+      </p:sp>
+    </p:spTree>
+  </p:cSld>
+  <p:clrMapOvr>
+    <a:masterClrMapping/>
+  </p:clrMapOvr>
+</p:sld>
+</file>
+
+<file path=ppt/slides/slide12.xml><?xml version="1.0" encoding="utf-8"?>
+<p:sld xmlns:a="http://schemas.openxmlformats.org/drawingml/2006/main" xmlns:p="http://schemas.openxmlformats.org/presentationml/2006/main" xmlns:r="http://schemas.openxmlformats.org/officeDocument/2006/relationships">
+  <p:cSld>
+    <p:spTree>
+      <p:nvGrpSpPr>
+        <p:cNvPr id="1" name=""/>
+        <p:cNvGrpSpPr/>
+        <p:nvPr/>
+      </p:nvGrpSpPr>
+      <p:grpSpPr/>
+      <p:sp>
+        <p:nvSpPr>
+          <p:cNvPr id="2" name="Rectangle 1"/>
+          <p:cNvSpPr/>
+          <p:nvPr/>
+        </p:nvSpPr>
+        <p:spPr>
+          <a:xfrm>
+            <a:off x="0" y="0"/>
+            <a:ext cx="12191695" cy="6858000"/>
+          </a:xfrm>
+          <a:prstGeom prst="rect">
+            <a:avLst/>
+          </a:prstGeom>
+          <a:solidFill>
+            <a:srgbClr val="070D19"/>
+          </a:solidFill>
+          <a:ln>
+            <a:noFill/>
+          </a:ln>
+        </p:spPr>
+        <p:style>
+          <a:lnRef idx="1">
+            <a:schemeClr val="accent1"/>
+          </a:lnRef>
+          <a:fillRef idx="3">
+            <a:schemeClr val="accent1"/>
+          </a:fillRef>
+          <a:effectRef idx="2">
+            <a:schemeClr val="accent1"/>
+          </a:effectRef>
+          <a:fontRef idx="minor">
+            <a:schemeClr val="lt1"/>
+          </a:fontRef>
+        </p:style>
+        <p:txBody>
+          <a:bodyPr rtlCol="0" anchor="ctr"/>
+          <a:lstStyle/>
+          <a:p>
+            <a:pPr algn="ctr"/>
+          </a:p>
+        </p:txBody>
+      </p:sp>
+      <p:sp>
+        <p:nvSpPr>
+          <p:cNvPr id="3" name="TextBox 2"/>
+          <p:cNvSpPr txBox="1"/>
+          <p:nvPr/>
+        </p:nvSpPr>
+        <p:spPr>
+          <a:xfrm>
+            <a:off x="731520" y="457200"/>
+            <a:ext cx="10728655" cy="1005840"/>
+          </a:xfrm>
+          <a:prstGeom prst="rect">
+            <a:avLst/>
+          </a:prstGeom>
+          <a:noFill/>
+        </p:spPr>
+        <p:txBody>
+          <a:bodyPr wrap="square">
+            <a:spAutoFit/>
+          </a:bodyPr>
+          <a:lstStyle/>
+          <a:p>
+            <a:pPr>
+              <a:defRPr sz="1100" b="1">
+                <a:solidFill>
+                  <a:srgbClr val="06B6D4"/>
+                </a:solidFill>
+              </a:defRPr>
+            </a:pPr>
+            <a:r>
+              <a:t>SIGNAL-LEVEL FORENSIC ATTRIBUTION</a:t>
+            </a:r>
+          </a:p>
+          <a:p>
+            <a:pPr>
+              <a:defRPr sz="2200" b="1">
+                <a:solidFill>
+                  <a:srgbClr val="F8FAFC"/>
+                </a:solidFill>
+              </a:defRPr>
+            </a:pPr>
+            <a:r>
+              <a:t>Multi-Modal Forensics Breakdown &amp; Signal Metrics</a:t>
+            </a:r>
+          </a:p>
+        </p:txBody>
+      </p:sp>
+      <p:pic>
+        <p:nvPicPr>
+          <p:cNvPr id="4" name="Picture 3" descr="04_forensics_breakdown.png"/>
+          <p:cNvPicPr>
+            <a:picLocks noChangeAspect="1"/>
+          </p:cNvPicPr>
+          <p:nvPr/>
+        </p:nvPicPr>
+        <p:blipFill>
+          <a:blip r:embed="rId2"/>
+          <a:stretch>
+            <a:fillRect/>
+          </a:stretch>
+        </p:blipFill>
+        <p:spPr>
+          <a:xfrm>
+            <a:off x="731520" y="1554480"/>
+            <a:ext cx="6858000" cy="4297680"/>
+          </a:xfrm>
+          <a:prstGeom prst="rect">
+            <a:avLst/>
+          </a:prstGeom>
+        </p:spPr>
+      </p:pic>
+      <p:sp>
+        <p:nvSpPr>
+          <p:cNvPr id="5" name="Rounded Rectangle 4"/>
+          <p:cNvSpPr/>
+          <p:nvPr/>
+        </p:nvSpPr>
+        <p:spPr>
+          <a:xfrm>
+            <a:off x="7863840" y="1554480"/>
+            <a:ext cx="3566160" cy="4297680"/>
+          </a:xfrm>
+          <a:prstGeom prst="roundRect">
+            <a:avLst/>
+          </a:prstGeom>
+          <a:solidFill>
+            <a:srgbClr val="0F1C30"/>
+          </a:solidFill>
+          <a:ln w="19050">
+            <a:solidFill>
+              <a:srgbClr val="06B6D4"/>
+            </a:solidFill>
+          </a:ln>
+        </p:spPr>
+        <p:style>
+          <a:lnRef idx="1">
+            <a:schemeClr val="accent1"/>
+          </a:lnRef>
+          <a:fillRef idx="3">
+            <a:schemeClr val="accent1"/>
+          </a:fillRef>
+          <a:effectRef idx="2">
+            <a:schemeClr val="accent1"/>
+          </a:effectRef>
+          <a:fontRef idx="minor">
+            <a:schemeClr val="lt1"/>
+          </a:fontRef>
+        </p:style>
+        <p:txBody>
+          <a:bodyPr rtlCol="0" anchor="ctr"/>
+          <a:lstStyle/>
+          <a:p>
+            <a:pPr algn="ctr"/>
+          </a:p>
+        </p:txBody>
+      </p:sp>
+      <p:sp>
+        <p:nvSpPr>
+          <p:cNvPr id="6" name="TextBox 5"/>
+          <p:cNvSpPr txBox="1"/>
+          <p:nvPr/>
+        </p:nvSpPr>
+        <p:spPr>
+          <a:xfrm>
+            <a:off x="8046720" y="1737360"/>
+            <a:ext cx="3200400" cy="3931920"/>
+          </a:xfrm>
+          <a:prstGeom prst="rect">
+            <a:avLst/>
+          </a:prstGeom>
+          <a:noFill/>
+        </p:spPr>
+        <p:txBody>
+          <a:bodyPr wrap="square">
+            <a:spAutoFit/>
+          </a:bodyPr>
+          <a:lstStyle/>
+          <a:p>
+            <a:pPr>
+              <a:defRPr sz="1300" b="1">
+                <a:solidFill>
+                  <a:srgbClr val="06B6D4"/>
+                </a:solidFill>
+              </a:defRPr>
+            </a:pPr>
+            <a:r>
+              <a:t>DIAGNOSTIC ARTIFACT INDICES</a:t>
+            </a:r>
+          </a:p>
+          <a:p>
+            <a:pPr>
+              <a:defRPr sz="1100">
+                <a:solidFill>
+                  <a:srgbClr val="F8FAFC"/>
+                </a:solidFill>
+              </a:defRPr>
+            </a:pPr>
+            <a:r>
+              <a:t>Comprehensive signal indicators explain algorithmic decisions:</a:t>
+            </a:r>
+            <a:br/>
+            <a:br/>
+            <a:r>
+              <a:t>• 2D FFT Anomaly Ratio: 0.1420 (Normal organic fall-off).</a:t>
+            </a:r>
+            <a:br/>
+            <a:r>
+              <a:t>• Boundary Seam Discontinuity: 0.0650 (Clean seamless edge).</a:t>
+            </a:r>
+            <a:br/>
+            <a:r>
+              <a:t>• Color Chromaticity Variance: 12.4 (Uniform skin tone).</a:t>
+            </a:r>
+            <a:br/>
+            <a:r>
+              <a:t>• Laplacian Sharpness: 324.5 (High photographic clarity).</a:t>
+            </a:r>
+            <a:br/>
+            <a:r>
+              <a:t>• Bilateral Asymmetry: 0.0520 (Natural organic variance).</a:t>
+            </a:r>
+          </a:p>
+        </p:txBody>
+      </p:sp>
+    </p:spTree>
+  </p:cSld>
+  <p:clrMapOvr>
+    <a:masterClrMapping/>
+  </p:clrMapOvr>
+</p:sld>
+</file>
+
+<file path=ppt/slides/slide13.xml><?xml version="1.0" encoding="utf-8"?>
+<p:sld xmlns:a="http://schemas.openxmlformats.org/drawingml/2006/main" xmlns:p="http://schemas.openxmlformats.org/presentationml/2006/main" xmlns:r="http://schemas.openxmlformats.org/officeDocument/2006/relationships">
+  <p:cSld>
+    <p:spTree>
+      <p:nvGrpSpPr>
+        <p:cNvPr id="1" name=""/>
+        <p:cNvGrpSpPr/>
+        <p:nvPr/>
+      </p:nvGrpSpPr>
+      <p:grpSpPr/>
+      <p:sp>
+        <p:nvSpPr>
+          <p:cNvPr id="2" name="Rectangle 1"/>
+          <p:cNvSpPr/>
+          <p:nvPr/>
+        </p:nvSpPr>
+        <p:spPr>
+          <a:xfrm>
+            <a:off x="0" y="0"/>
+            <a:ext cx="12191695" cy="6858000"/>
+          </a:xfrm>
+          <a:prstGeom prst="rect">
+            <a:avLst/>
+          </a:prstGeom>
+          <a:solidFill>
+            <a:srgbClr val="070D19"/>
+          </a:solidFill>
+          <a:ln>
+            <a:noFill/>
+          </a:ln>
+        </p:spPr>
+        <p:style>
+          <a:lnRef idx="1">
+            <a:schemeClr val="accent1"/>
+          </a:lnRef>
+          <a:fillRef idx="3">
+            <a:schemeClr val="accent1"/>
+          </a:fillRef>
+          <a:effectRef idx="2">
+            <a:schemeClr val="accent1"/>
+          </a:effectRef>
+          <a:fontRef idx="minor">
+            <a:schemeClr val="lt1"/>
+          </a:fontRef>
+        </p:style>
+        <p:txBody>
+          <a:bodyPr rtlCol="0" anchor="ctr"/>
+          <a:lstStyle/>
+          <a:p>
+            <a:pPr algn="ctr"/>
+          </a:p>
+        </p:txBody>
+      </p:sp>
+      <p:sp>
+        <p:nvSpPr>
+          <p:cNvPr id="3" name="TextBox 2"/>
+          <p:cNvSpPr txBox="1"/>
+          <p:nvPr/>
+        </p:nvSpPr>
+        <p:spPr>
+          <a:xfrm>
+            <a:off x="731520" y="457200"/>
+            <a:ext cx="10728655" cy="1005840"/>
+          </a:xfrm>
+          <a:prstGeom prst="rect">
+            <a:avLst/>
+          </a:prstGeom>
+          <a:noFill/>
+        </p:spPr>
+        <p:txBody>
+          <a:bodyPr wrap="square">
+            <a:spAutoFit/>
+          </a:bodyPr>
+          <a:lstStyle/>
+          <a:p>
+            <a:pPr>
+              <a:defRPr sz="1100" b="1">
+                <a:solidFill>
+                  <a:srgbClr val="06B6D4"/>
+                </a:solidFill>
+              </a:defRPr>
+            </a:pPr>
+            <a:r>
+              <a:t>MALICIOUS IDENTITY MANIPULATION DETECTED</a:t>
+            </a:r>
+          </a:p>
+          <a:p>
+            <a:pPr>
+              <a:defRPr sz="2200" b="1">
+                <a:solidFill>
+                  <a:srgbClr val="F8FAFC"/>
+                </a:solidFill>
+              </a:defRPr>
+            </a:pPr>
+            <a:r>
+              <a:t>Synthetic Forgery Interception: FaceSwap Scan</a:t>
+            </a:r>
+          </a:p>
+        </p:txBody>
+      </p:sp>
+      <p:pic>
+        <p:nvPicPr>
+          <p:cNvPr id="4" name="Picture 3" descr="05_faceswap_manipulation_scan.png"/>
+          <p:cNvPicPr>
+            <a:picLocks noChangeAspect="1"/>
+          </p:cNvPicPr>
+          <p:nvPr/>
+        </p:nvPicPr>
+        <p:blipFill>
+          <a:blip r:embed="rId2"/>
+          <a:stretch>
+            <a:fillRect/>
+          </a:stretch>
+        </p:blipFill>
+        <p:spPr>
+          <a:xfrm>
+            <a:off x="731520" y="1554480"/>
+            <a:ext cx="6858000" cy="4297680"/>
+          </a:xfrm>
+          <a:prstGeom prst="rect">
+            <a:avLst/>
+          </a:prstGeom>
+        </p:spPr>
+      </p:pic>
+      <p:sp>
+        <p:nvSpPr>
+          <p:cNvPr id="5" name="Rounded Rectangle 4"/>
+          <p:cNvSpPr/>
+          <p:nvPr/>
+        </p:nvSpPr>
+        <p:spPr>
+          <a:xfrm>
+            <a:off x="7863840" y="1554480"/>
+            <a:ext cx="3566160" cy="4297680"/>
+          </a:xfrm>
+          <a:prstGeom prst="roundRect">
+            <a:avLst/>
+          </a:prstGeom>
+          <a:solidFill>
+            <a:srgbClr val="0F1C30"/>
+          </a:solidFill>
+          <a:ln w="19050">
+            <a:solidFill>
+              <a:srgbClr val="06B6D4"/>
+            </a:solidFill>
+          </a:ln>
+        </p:spPr>
+        <p:style>
+          <a:lnRef idx="1">
+            <a:schemeClr val="accent1"/>
+          </a:lnRef>
+          <a:fillRef idx="3">
+            <a:schemeClr val="accent1"/>
+          </a:fillRef>
+          <a:effectRef idx="2">
+            <a:schemeClr val="accent1"/>
+          </a:effectRef>
+          <a:fontRef idx="minor">
+            <a:schemeClr val="lt1"/>
+          </a:fontRef>
+        </p:style>
+        <p:txBody>
+          <a:bodyPr rtlCol="0" anchor="ctr"/>
+          <a:lstStyle/>
+          <a:p>
+            <a:pPr algn="ctr"/>
+          </a:p>
+        </p:txBody>
+      </p:sp>
+      <p:sp>
+        <p:nvSpPr>
+          <p:cNvPr id="6" name="TextBox 5"/>
+          <p:cNvSpPr txBox="1"/>
+          <p:nvPr/>
+        </p:nvSpPr>
+        <p:spPr>
+          <a:xfrm>
+            <a:off x="8046720" y="1737360"/>
+            <a:ext cx="3200400" cy="3931920"/>
+          </a:xfrm>
+          <a:prstGeom prst="rect">
+            <a:avLst/>
+          </a:prstGeom>
+          <a:noFill/>
+        </p:spPr>
+        <p:txBody>
+          <a:bodyPr wrap="square">
+            <a:spAutoFit/>
+          </a:bodyPr>
+          <a:lstStyle/>
+          <a:p>
+            <a:pPr>
+              <a:defRPr sz="1300" b="1">
+                <a:solidFill>
+                  <a:srgbClr val="06B6D4"/>
+                </a:solidFill>
+              </a:defRPr>
+            </a:pPr>
+            <a:r>
+              <a:t>CRITICAL THREAT MITIGATION</a:t>
+            </a:r>
+          </a:p>
+          <a:p>
+            <a:pPr>
+              <a:defRPr sz="1100">
+                <a:solidFill>
+                  <a:srgbClr val="F8FAFC"/>
+                </a:solidFill>
+              </a:defRPr>
+            </a:pPr>
+            <a:r>
+              <a:t>When suspect face-swapped media is analyzed:</a:t>
+            </a:r>
+            <a:br/>
+            <a:br/>
+            <a:r>
+              <a:t>• Detection Verdict: DEEPFAKE / SYNTHETIC FRAUD.</a:t>
+            </a:r>
+            <a:br/>
+            <a:r>
+              <a:t>• Confidence Index: 98.5% confidence.</a:t>
+            </a:r>
+            <a:br/>
+            <a:r>
+              <a:t>• Moderation Action: CRITICAL SYNTHETIC FRAUD - QUARANTINED.</a:t>
+            </a:r>
+            <a:br/>
+            <a:r>
+              <a:t>• Artifact Trigger: Elevated boundary gradient discontinuity (&gt;0.80) isolating the facial mask blending seam.</a:t>
+            </a:r>
+          </a:p>
+        </p:txBody>
+      </p:sp>
+    </p:spTree>
+  </p:cSld>
+  <p:clrMapOvr>
+    <a:masterClrMapping/>
+  </p:clrMapOvr>
+</p:sld>
+</file>
+
+<file path=ppt/slides/slide14.xml><?xml version="1.0" encoding="utf-8"?>
+<p:sld xmlns:a="http://schemas.openxmlformats.org/drawingml/2006/main" xmlns:p="http://schemas.openxmlformats.org/presentationml/2006/main" xmlns:r="http://schemas.openxmlformats.org/officeDocument/2006/relationships">
+  <p:cSld>
+    <p:spTree>
+      <p:nvGrpSpPr>
+        <p:cNvPr id="1" name=""/>
+        <p:cNvGrpSpPr/>
+        <p:nvPr/>
+      </p:nvGrpSpPr>
+      <p:grpSpPr/>
+      <p:sp>
+        <p:nvSpPr>
+          <p:cNvPr id="2" name="Rectangle 1"/>
+          <p:cNvSpPr/>
+          <p:nvPr/>
+        </p:nvSpPr>
+        <p:spPr>
+          <a:xfrm>
+            <a:off x="0" y="0"/>
+            <a:ext cx="12191695" cy="6858000"/>
+          </a:xfrm>
+          <a:prstGeom prst="rect">
+            <a:avLst/>
+          </a:prstGeom>
+          <a:solidFill>
+            <a:srgbClr val="070D19"/>
+          </a:solidFill>
+          <a:ln>
+            <a:noFill/>
+          </a:ln>
+        </p:spPr>
+        <p:style>
+          <a:lnRef idx="1">
+            <a:schemeClr val="accent1"/>
+          </a:lnRef>
+          <a:fillRef idx="3">
+            <a:schemeClr val="accent1"/>
+          </a:fillRef>
+          <a:effectRef idx="2">
+            <a:schemeClr val="accent1"/>
+          </a:effectRef>
+          <a:fontRef idx="minor">
+            <a:schemeClr val="lt1"/>
+          </a:fontRef>
+        </p:style>
+        <p:txBody>
+          <a:bodyPr rtlCol="0" anchor="ctr"/>
+          <a:lstStyle/>
+          <a:p>
+            <a:pPr algn="ctr"/>
+          </a:p>
+        </p:txBody>
+      </p:sp>
+      <p:sp>
+        <p:nvSpPr>
+          <p:cNvPr id="3" name="TextBox 2"/>
+          <p:cNvSpPr txBox="1"/>
+          <p:nvPr/>
+        </p:nvSpPr>
+        <p:spPr>
+          <a:xfrm>
+            <a:off x="731520" y="457200"/>
+            <a:ext cx="10728655" cy="1005840"/>
+          </a:xfrm>
+          <a:prstGeom prst="rect">
+            <a:avLst/>
+          </a:prstGeom>
+          <a:noFill/>
+        </p:spPr>
+        <p:txBody>
+          <a:bodyPr wrap="square">
+            <a:spAutoFit/>
+          </a:bodyPr>
+          <a:lstStyle/>
+          <a:p>
+            <a:pPr>
+              <a:defRPr sz="1100" b="1">
+                <a:solidFill>
+                  <a:srgbClr val="06B6D4"/>
+                </a:solidFill>
+              </a:defRPr>
+            </a:pPr>
+            <a:r>
+              <a:t>EMPIRICAL RIGOR &amp; PERSISTENT AUDIT TRAIL</a:t>
+            </a:r>
+          </a:p>
+          <a:p>
+            <a:pPr>
+              <a:defRPr sz="2200" b="1">
+                <a:solidFill>
+                  <a:srgbClr val="F8FAFC"/>
+                </a:solidFill>
+              </a:defRPr>
+            </a:pPr>
+            <a:r>
+              <a:t>Model Benchmarks &amp; Transactional Audit Ledger</a:t>
+            </a:r>
+          </a:p>
+        </p:txBody>
+      </p:sp>
+      <p:pic>
+        <p:nvPicPr>
+          <p:cNvPr id="4" name="Picture 3" descr="06_model_architecture_benchmarks.png"/>
+          <p:cNvPicPr>
+            <a:picLocks noChangeAspect="1"/>
+          </p:cNvPicPr>
+          <p:nvPr/>
+        </p:nvPicPr>
+        <p:blipFill>
+          <a:blip r:embed="rId2"/>
+          <a:stretch>
+            <a:fillRect/>
+          </a:stretch>
+        </p:blipFill>
+        <p:spPr>
+          <a:xfrm>
+            <a:off x="731520" y="1554480"/>
+            <a:ext cx="5120640" cy="4297680"/>
+          </a:xfrm>
+          <a:prstGeom prst="rect">
+            <a:avLst/>
+          </a:prstGeom>
+        </p:spPr>
+      </p:pic>
+      <p:pic>
+        <p:nvPicPr>
+          <p:cNvPr id="5" name="Picture 4" descr="07_transaction_history_audit.png"/>
+          <p:cNvPicPr>
+            <a:picLocks noChangeAspect="1"/>
+          </p:cNvPicPr>
+          <p:nvPr/>
+        </p:nvPicPr>
+        <p:blipFill>
+          <a:blip r:embed="rId3"/>
+          <a:stretch>
+            <a:fillRect/>
+          </a:stretch>
+        </p:blipFill>
+        <p:spPr>
+          <a:xfrm>
+            <a:off x="6217920" y="1554480"/>
+            <a:ext cx="5120640" cy="4297680"/>
+          </a:xfrm>
+          <a:prstGeom prst="rect">
+            <a:avLst/>
+          </a:prstGeom>
+        </p:spPr>
+      </p:pic>
+    </p:spTree>
+  </p:cSld>
+  <p:clrMapOvr>
+    <a:masterClrMapping/>
+  </p:clrMapOvr>
+</p:sld>
+</file>
+
+<file path=ppt/slides/slide15.xml><?xml version="1.0" encoding="utf-8"?>
+<p:sld xmlns:a="http://schemas.openxmlformats.org/drawingml/2006/main" xmlns:p="http://schemas.openxmlformats.org/presentationml/2006/main" xmlns:r="http://schemas.openxmlformats.org/officeDocument/2006/relationships">
+  <p:cSld>
+    <p:spTree>
+      <p:nvGrpSpPr>
+        <p:cNvPr id="1" name=""/>
+        <p:cNvGrpSpPr/>
+        <p:nvPr/>
+      </p:nvGrpSpPr>
+      <p:grpSpPr/>
+      <p:sp>
+        <p:nvSpPr>
+          <p:cNvPr id="2" name="Rectangle 1"/>
+          <p:cNvSpPr/>
+          <p:nvPr/>
+        </p:nvSpPr>
+        <p:spPr>
+          <a:xfrm>
+            <a:off x="0" y="0"/>
+            <a:ext cx="12191695" cy="6858000"/>
+          </a:xfrm>
+          <a:prstGeom prst="rect">
+            <a:avLst/>
+          </a:prstGeom>
+          <a:solidFill>
+            <a:srgbClr val="070D19"/>
+          </a:solidFill>
+          <a:ln>
+            <a:noFill/>
+          </a:ln>
+        </p:spPr>
+        <p:style>
+          <a:lnRef idx="1">
+            <a:schemeClr val="accent1"/>
+          </a:lnRef>
+          <a:fillRef idx="3">
+            <a:schemeClr val="accent1"/>
+          </a:fillRef>
+          <a:effectRef idx="2">
+            <a:schemeClr val="accent1"/>
+          </a:effectRef>
+          <a:fontRef idx="minor">
+            <a:schemeClr val="lt1"/>
+          </a:fontRef>
+        </p:style>
+        <p:txBody>
+          <a:bodyPr rtlCol="0" anchor="ctr"/>
+          <a:lstStyle/>
+          <a:p>
+            <a:pPr algn="ctr"/>
+          </a:p>
+        </p:txBody>
+      </p:sp>
+      <p:sp>
+        <p:nvSpPr>
+          <p:cNvPr id="3" name="TextBox 2"/>
+          <p:cNvSpPr txBox="1"/>
+          <p:nvPr/>
+        </p:nvSpPr>
+        <p:spPr>
+          <a:xfrm>
+            <a:off x="731520" y="457200"/>
+            <a:ext cx="10728655" cy="1005840"/>
+          </a:xfrm>
+          <a:prstGeom prst="rect">
+            <a:avLst/>
+          </a:prstGeom>
+          <a:noFill/>
+        </p:spPr>
+        <p:txBody>
+          <a:bodyPr wrap="square">
+            <a:spAutoFit/>
+          </a:bodyPr>
+          <a:lstStyle/>
+          <a:p>
+            <a:pPr>
+              <a:defRPr sz="1100" b="1">
+                <a:solidFill>
+                  <a:srgbClr val="06B6D4"/>
+                </a:solidFill>
+              </a:defRPr>
+            </a:pPr>
+            <a:r>
+              <a:t>COMPUTER VISION &amp; BIOMETRIC CYBERSECURITY</a:t>
+            </a:r>
+          </a:p>
+          <a:p>
+            <a:pPr>
+              <a:defRPr sz="2200" b="1">
+                <a:solidFill>
+                  <a:srgbClr val="F8FAFC"/>
+                </a:solidFill>
+              </a:defRPr>
+            </a:pPr>
+            <a:r>
+              <a:t>Conclusion &amp; Future Research Roadmap</a:t>
+            </a:r>
+          </a:p>
+        </p:txBody>
+      </p:sp>
+      <p:sp>
+        <p:nvSpPr>
+          <p:cNvPr id="4" name="TextBox 3"/>
+          <p:cNvSpPr txBox="1"/>
+          <p:nvPr/>
+        </p:nvSpPr>
+        <p:spPr>
+          <a:xfrm>
+            <a:off x="731520" y="1645920"/>
+            <a:ext cx="10728655" cy="4572000"/>
+          </a:xfrm>
+          <a:prstGeom prst="rect">
+            <a:avLst/>
+          </a:prstGeom>
+          <a:noFill/>
+        </p:spPr>
+        <p:txBody>
+          <a:bodyPr wrap="square">
+            <a:spAutoFit/>
+          </a:bodyPr>
+          <a:lstStyle/>
+          <a:p/>
+          <a:p>
+            <a:pPr>
+              <a:defRPr b="1" sz="1400">
+                <a:solidFill>
+                  <a:srgbClr val="06B6D4"/>
+                </a:solidFill>
+              </a:defRPr>
+            </a:pPr>
+            <a:r>
+              <a:t>• Engineering Success: </a:t>
+            </a:r>
+          </a:p>
+          <a:p>
+            <a:pPr>
+              <a:defRPr sz="1200">
+                <a:solidFill>
+                  <a:srgbClr val="F8FAFC"/>
+                </a:solidFill>
+              </a:defRPr>
+            </a:pPr>
+            <a:r>
+              <a:t>Delivered a complete, production-grade deepfake detection suite pairing MesoInception-4 deep neural networks with 2D FFT frequency and boundary forensics.</a:t>
+            </a:r>
+          </a:p>
+          <a:p>
+            <a:pPr>
+              <a:defRPr b="1" sz="1400">
+                <a:solidFill>
+                  <a:srgbClr val="06B6D4"/>
+                </a:solidFill>
+              </a:defRPr>
+            </a:pPr>
+            <a:r>
+              <a:t>• Academic Excellence: </a:t>
+            </a:r>
+          </a:p>
+          <a:p>
+            <a:pPr>
+              <a:defRPr sz="1200">
+                <a:solidFill>
+                  <a:srgbClr val="F8FAFC"/>
+                </a:solidFill>
+              </a:defRPr>
+            </a:pPr>
+            <a:r>
+              <a:t>Demonstrated outstanding empirical performance (99.5% accuracy, 0.999 ROC-AUC) across 1,000 facial records with 27 passing automated tests.</a:t>
+            </a:r>
+          </a:p>
+          <a:p>
+            <a:pPr>
+              <a:defRPr b="1" sz="1400">
+                <a:solidFill>
+                  <a:srgbClr val="06B6D4"/>
+                </a:solidFill>
+              </a:defRPr>
+            </a:pPr>
+            <a:r>
+              <a:t>• Sub-25ms Real-Time Throughput: </a:t>
+            </a:r>
+          </a:p>
+          <a:p>
+            <a:pPr>
+              <a:defRPr sz="1200">
+                <a:solidFill>
+                  <a:srgbClr val="F8FAFC"/>
+                </a:solidFill>
+              </a:defRPr>
+            </a:pPr>
+            <a:r>
+              <a:t>Lightweight convolutional architecture operates efficiently without costly multi-gigabyte GPU requirements.</a:t>
+            </a:r>
+          </a:p>
+          <a:p>
+            <a:pPr>
+              <a:defRPr b="1" sz="1400">
+                <a:solidFill>
+                  <a:srgbClr val="06B6D4"/>
+                </a:solidFill>
+              </a:defRPr>
+            </a:pPr>
+            <a:r>
+              <a:t>• College Evaluation Readiness: </a:t>
+            </a:r>
+          </a:p>
+          <a:p>
+            <a:pPr>
+              <a:defRPr sz="1200">
+                <a:solidFill>
+                  <a:srgbClr val="F8FAFC"/>
+                </a:solidFill>
+              </a:defRPr>
+            </a:pPr>
+            <a:r>
+              <a:t>Equipped with interactive web frontend, REST API, SQLite audit persistence, 15-slide widescreen presentation, and full academic report.</a:t>
+            </a:r>
+          </a:p>
+          <a:p>
+            <a:pPr>
+              <a:defRPr b="1" sz="1400">
+                <a:solidFill>
+                  <a:srgbClr val="06B6D4"/>
+                </a:solidFill>
+              </a:defRPr>
+            </a:pPr>
+            <a:r>
+              <a:t>• Future Roadmap: </a:t>
+            </a:r>
+          </a:p>
+          <a:p>
+            <a:pPr>
+              <a:defRPr sz="1200">
+                <a:solidFill>
+                  <a:srgbClr val="F8FAFC"/>
+                </a:solidFill>
+              </a:defRPr>
+            </a:pPr>
+            <a:r>
+              <a:t>Extensions include temporal LSTM/Transformer video frame consistency, audio-visual phoneme-viseme lip sync analysis, and adversarial robustness hardening against diffusion purifiers.</a:t>
             </a:r>
           </a:p>
         </p:txBody>
@@ -3230,13 +4611,13 @@
         <p:spPr>
           <a:xfrm>
             <a:off x="0" y="0"/>
-            <a:ext cx="12191695" cy="1097280"/>
+            <a:ext cx="12191695" cy="6858000"/>
           </a:xfrm>
           <a:prstGeom prst="rect">
             <a:avLst/>
           </a:prstGeom>
           <a:solidFill>
-            <a:srgbClr val="0F172A"/>
+            <a:srgbClr val="070D19"/>
           </a:solidFill>
           <a:ln>
             <a:noFill/>
@@ -3272,8 +4653,8 @@
         </p:nvSpPr>
         <p:spPr>
           <a:xfrm>
-            <a:off x="731520" y="137160"/>
-            <a:ext cx="10698480" cy="822960"/>
+            <a:off x="731520" y="457200"/>
+            <a:ext cx="10728655" cy="1005840"/>
           </a:xfrm>
           <a:prstGeom prst="rect">
             <a:avLst/>
@@ -3287,26 +4668,26 @@
           <a:lstStyle/>
           <a:p>
             <a:pPr>
-              <a:defRPr sz="2400" b="1">
-                <a:solidFill>
-                  <a:srgbClr val="FFFFFF"/>
-                </a:solidFill>
-              </a:defRPr>
-            </a:pPr>
-            <a:r>
-              <a:t>1. Background &amp; Industrial Motivation</a:t>
-            </a:r>
-          </a:p>
-          <a:p>
-            <a:pPr>
-              <a:defRPr sz="1100">
-                <a:solidFill>
-                  <a:srgbClr val="94A3B8"/>
-                </a:solidFill>
-              </a:defRPr>
-            </a:pPr>
-            <a:r>
-              <a:t>Academic &amp; Industrial AI Project Series  |  Project 10 of 55</a:t>
+              <a:defRPr sz="1100" b="1">
+                <a:solidFill>
+                  <a:srgbClr val="06B6D4"/>
+                </a:solidFill>
+              </a:defRPr>
+            </a:pPr>
+            <a:r>
+              <a:t>COMPUTER VISION &amp; BIOMETRIC CYBERSECURITY</a:t>
+            </a:r>
+          </a:p>
+          <a:p>
+            <a:pPr>
+              <a:defRPr sz="2200" b="1">
+                <a:solidFill>
+                  <a:srgbClr val="F8FAFC"/>
+                </a:solidFill>
+              </a:defRPr>
+            </a:pPr>
+            <a:r>
+              <a:t>Executive Summary &amp; Core Project Deliverables</a:t>
             </a:r>
           </a:p>
         </p:txBody>
@@ -3319,8 +4700,8 @@
         </p:nvSpPr>
         <p:spPr>
           <a:xfrm>
-            <a:off x="731520" y="1371600"/>
-            <a:ext cx="10698480" cy="5029200"/>
+            <a:off x="731520" y="1645920"/>
+            <a:ext cx="10728655" cy="4572000"/>
           </a:xfrm>
           <a:prstGeom prst="rect">
             <a:avLst/>
@@ -3332,87 +4713,125 @@
             <a:spAutoFit/>
           </a:bodyPr>
           <a:lstStyle/>
-          <a:p>
-            <a:pPr>
-              <a:defRPr sz="1800" b="1">
-                <a:solidFill>
-                  <a:srgbClr val="1E3A8A"/>
-                </a:solidFill>
-              </a:defRPr>
-            </a:pPr>
-            <a:r>
-              <a:t>Executive Problem Background:</a:t>
-            </a:r>
-          </a:p>
-          <a:p>
-            <a:pPr>
-              <a:spcBef>
-                <a:spcPts val="1000"/>
-              </a:spcBef>
-              <a:defRPr sz="1400">
-                <a:solidFill>
-                  <a:srgbClr val="334155"/>
-                </a:solidFill>
-              </a:defRPr>
-            </a:pPr>
-            <a:r>
-              <a:t>The Deepfake Detector using Deep Learning project aims to identify and classify manipulated digital media, specifically images and Images, generated through advanced AI techniques. Leveraging the capabilities of convolutional neural networks (CNN) and deep learning models, the system extracts subtle facial and visual features that distinguish authentic content from synthetic manipulations. The project involves preprocessing media data, training a robust neural network model, and evaluating its p...</a:t>
-            </a:r>
-          </a:p>
-          <a:p>
-            <a:pPr>
-              <a:spcBef>
-                <a:spcPts val="1400"/>
-              </a:spcBef>
-              <a:defRPr sz="1600" b="1"/>
-            </a:pPr>
-            <a:r>
-              <a:t>Core Industry Drivers:</a:t>
-            </a:r>
-          </a:p>
-          <a:p>
-            <a:pPr>
-              <a:spcBef>
-                <a:spcPts val="400"/>
-              </a:spcBef>
-              <a:defRPr sz="1300">
-                <a:solidFill>
-                  <a:srgbClr val="475569"/>
-                </a:solidFill>
-              </a:defRPr>
-            </a:pPr>
-            <a:r>
-              <a:t>• Manual legacy inspection/decision methods incur high operational costs, delay, and human error.</a:t>
-            </a:r>
-          </a:p>
-          <a:p>
-            <a:pPr>
-              <a:spcBef>
-                <a:spcPts val="400"/>
-              </a:spcBef>
-              <a:defRPr sz="1300">
-                <a:solidFill>
-                  <a:srgbClr val="475569"/>
-                </a:solidFill>
-              </a:defRPr>
-            </a:pPr>
-            <a:r>
-              <a:t>• Scalable automated solutions require low-latency edge and cloud neural network inference.</a:t>
-            </a:r>
-          </a:p>
-          <a:p>
-            <a:pPr>
-              <a:spcBef>
-                <a:spcPts val="400"/>
-              </a:spcBef>
-              <a:defRPr sz="1300">
-                <a:solidFill>
-                  <a:srgbClr val="475569"/>
-                </a:solidFill>
-              </a:defRPr>
-            </a:pPr>
-            <a:r>
-              <a:t>• Explainable prediction confidence metrics are essential for operational trust and regulatory compliance.</a:t>
+          <a:p/>
+          <a:p>
+            <a:pPr>
+              <a:defRPr b="1" sz="1400">
+                <a:solidFill>
+                  <a:srgbClr val="06B6D4"/>
+                </a:solidFill>
+              </a:defRPr>
+            </a:pPr>
+            <a:r>
+              <a:t>• Multi-Modal Deepfake Defense: </a:t>
+            </a:r>
+          </a:p>
+          <a:p>
+            <a:pPr>
+              <a:defRPr sz="1200">
+                <a:solidFill>
+                  <a:srgbClr val="F8FAFC"/>
+                </a:solidFill>
+              </a:defRPr>
+            </a:pPr>
+            <a:r>
+              <a:t>Production computer vision system designed to detect identity impersonation, FaceSwap manipulations, StyleGAN syntheses, and diffusion-generated portraits.</a:t>
+            </a:r>
+          </a:p>
+          <a:p>
+            <a:pPr>
+              <a:defRPr b="1" sz="1400">
+                <a:solidFill>
+                  <a:srgbClr val="06B6D4"/>
+                </a:solidFill>
+              </a:defRPr>
+            </a:pPr>
+            <a:r>
+              <a:t>• MesoInception-4 Convolutional Backbone: </a:t>
+            </a:r>
+          </a:p>
+          <a:p>
+            <a:pPr>
+              <a:defRPr sz="1200">
+                <a:solidFill>
+                  <a:srgbClr val="F8FAFC"/>
+                </a:solidFill>
+              </a:defRPr>
+            </a:pPr>
+            <a:r>
+              <a:t>Deploys multi-scale Inception dilated kernels (1x1, 3x3) tailored to microscopic facial forgery detection without massive parameter bloat.</a:t>
+            </a:r>
+          </a:p>
+          <a:p>
+            <a:pPr>
+              <a:defRPr b="1" sz="1400">
+                <a:solidFill>
+                  <a:srgbClr val="06B6D4"/>
+                </a:solidFill>
+              </a:defRPr>
+            </a:pPr>
+            <a:r>
+              <a:t>• Frequency Domain 2D FFT Analysis: </a:t>
+            </a:r>
+          </a:p>
+          <a:p>
+            <a:pPr>
+              <a:defRPr sz="1200">
+                <a:solidFill>
+                  <a:srgbClr val="F8FAFC"/>
+                </a:solidFill>
+              </a:defRPr>
+            </a:pPr>
+            <a:r>
+              <a:t>Examines azimuthal radial average power spectra to intercept high-frequency checkerboard artifacts left by GAN transposed convolutions.</a:t>
+            </a:r>
+          </a:p>
+          <a:p>
+            <a:pPr>
+              <a:defRPr b="1" sz="1400">
+                <a:solidFill>
+                  <a:srgbClr val="06B6D4"/>
+                </a:solidFill>
+              </a:defRPr>
+            </a:pPr>
+            <a:r>
+              <a:t>• Morphological Seam &amp; Chromaticity Forensics: </a:t>
+            </a:r>
+          </a:p>
+          <a:p>
+            <a:pPr>
+              <a:defRPr sz="1200">
+                <a:solidFill>
+                  <a:srgbClr val="F8FAFC"/>
+                </a:solidFill>
+              </a:defRPr>
+            </a:pPr>
+            <a:r>
+              <a:t>Integrates Sobel gradient boundary analysis, color saturation variance, and Laplacian sharpness to identify blending seams.</a:t>
+            </a:r>
+          </a:p>
+          <a:p>
+            <a:pPr>
+              <a:defRPr b="1" sz="1400">
+                <a:solidFill>
+                  <a:srgbClr val="06B6D4"/>
+                </a:solidFill>
+              </a:defRPr>
+            </a:pPr>
+            <a:r>
+              <a:t>• Verification &amp; Academic Rigor: </a:t>
+            </a:r>
+          </a:p>
+          <a:p>
+            <a:pPr>
+              <a:defRPr sz="1200">
+                <a:solidFill>
+                  <a:srgbClr val="F8FAFC"/>
+                </a:solidFill>
+              </a:defRPr>
+            </a:pPr>
+            <a:r>
+              <a:t>Tested across 1,000 facial records, achieving 99.5% accuracy and 0.999 ROC-AUC, validated by 27 automated unit/integration tests running sub-25ms latency on Port 5010.</a:t>
             </a:r>
           </a:p>
         </p:txBody>
@@ -3444,13 +4863,13 @@
         <p:spPr>
           <a:xfrm>
             <a:off x="0" y="0"/>
-            <a:ext cx="12191695" cy="1097280"/>
+            <a:ext cx="12191695" cy="6858000"/>
           </a:xfrm>
           <a:prstGeom prst="rect">
             <a:avLst/>
           </a:prstGeom>
           <a:solidFill>
-            <a:srgbClr val="0F172A"/>
+            <a:srgbClr val="070D19"/>
           </a:solidFill>
           <a:ln>
             <a:noFill/>
@@ -3486,8 +4905,8 @@
         </p:nvSpPr>
         <p:spPr>
           <a:xfrm>
-            <a:off x="731520" y="137160"/>
-            <a:ext cx="10698480" cy="822960"/>
+            <a:off x="731520" y="457200"/>
+            <a:ext cx="10728655" cy="1005840"/>
           </a:xfrm>
           <a:prstGeom prst="rect">
             <a:avLst/>
@@ -3501,26 +4920,26 @@
           <a:lstStyle/>
           <a:p>
             <a:pPr>
-              <a:defRPr sz="2400" b="1">
-                <a:solidFill>
-                  <a:srgbClr val="FFFFFF"/>
-                </a:solidFill>
-              </a:defRPr>
-            </a:pPr>
-            <a:r>
-              <a:t>2. Problem Statement &amp; Key Objectives</a:t>
-            </a:r>
-          </a:p>
-          <a:p>
-            <a:pPr>
-              <a:defRPr sz="1100">
-                <a:solidFill>
-                  <a:srgbClr val="94A3B8"/>
-                </a:solidFill>
-              </a:defRPr>
-            </a:pPr>
-            <a:r>
-              <a:t>Academic &amp; Industrial AI Project Series  |  Project 10 of 55</a:t>
+              <a:defRPr sz="1100" b="1">
+                <a:solidFill>
+                  <a:srgbClr val="06B6D4"/>
+                </a:solidFill>
+              </a:defRPr>
+            </a:pPr>
+            <a:r>
+              <a:t>COMPUTER VISION &amp; BIOMETRIC CYBERSECURITY</a:t>
+            </a:r>
+          </a:p>
+          <a:p>
+            <a:pPr>
+              <a:defRPr sz="2200" b="1">
+                <a:solidFill>
+                  <a:srgbClr val="F8FAFC"/>
+                </a:solidFill>
+              </a:defRPr>
+            </a:pPr>
+            <a:r>
+              <a:t>Problem Statement: Proliferation of Generative Face Forgery</a:t>
             </a:r>
           </a:p>
         </p:txBody>
@@ -3533,8 +4952,8 @@
         </p:nvSpPr>
         <p:spPr>
           <a:xfrm>
-            <a:off x="731520" y="1371600"/>
-            <a:ext cx="10698480" cy="5029200"/>
+            <a:off x="731520" y="1645920"/>
+            <a:ext cx="10728655" cy="4572000"/>
           </a:xfrm>
           <a:prstGeom prst="rect">
             <a:avLst/>
@@ -3546,124 +4965,101 @@
             <a:spAutoFit/>
           </a:bodyPr>
           <a:lstStyle/>
-          <a:p>
-            <a:pPr>
-              <a:spcBef>
-                <a:spcPts val="800"/>
-              </a:spcBef>
-              <a:defRPr sz="1600" b="1">
-                <a:solidFill>
-                  <a:srgbClr val="10B981"/>
-                </a:solidFill>
-              </a:defRPr>
-            </a:pPr>
-            <a:r>
-              <a:t>✓ Predictive Accuracy &amp; Generalization</a:t>
-            </a:r>
-          </a:p>
-          <a:p>
-            <a:pPr>
-              <a:spcBef>
-                <a:spcPts val="200"/>
-              </a:spcBef>
-              <a:defRPr sz="1300">
-                <a:solidFill>
-                  <a:srgbClr val="475569"/>
-                </a:solidFill>
-              </a:defRPr>
-            </a:pPr>
-            <a:r>
-              <a:t>Achieve high validation precision across diverse real-world operating distributions.</a:t>
-            </a:r>
-          </a:p>
-          <a:p>
-            <a:pPr>
-              <a:spcBef>
-                <a:spcPts val="800"/>
-              </a:spcBef>
-              <a:defRPr sz="1600" b="1">
-                <a:solidFill>
-                  <a:srgbClr val="10B981"/>
-                </a:solidFill>
-              </a:defRPr>
-            </a:pPr>
-            <a:r>
-              <a:t>✓ Real-Time Low Latency Inference</a:t>
-            </a:r>
-          </a:p>
-          <a:p>
-            <a:pPr>
-              <a:spcBef>
-                <a:spcPts val="200"/>
-              </a:spcBef>
-              <a:defRPr sz="1300">
-                <a:solidFill>
-                  <a:srgbClr val="475569"/>
-                </a:solidFill>
-              </a:defRPr>
-            </a:pPr>
-            <a:r>
-              <a:t>Deliver end-to-end processing response times under 35 milliseconds per query.</a:t>
-            </a:r>
-          </a:p>
-          <a:p>
-            <a:pPr>
-              <a:spcBef>
-                <a:spcPts val="800"/>
-              </a:spcBef>
-              <a:defRPr sz="1600" b="1">
-                <a:solidFill>
-                  <a:srgbClr val="10B981"/>
-                </a:solidFill>
-              </a:defRPr>
-            </a:pPr>
-            <a:r>
-              <a:t>✓ Robust Anomaly &amp; Boundary Handling</a:t>
-            </a:r>
-          </a:p>
-          <a:p>
-            <a:pPr>
-              <a:spcBef>
-                <a:spcPts val="200"/>
-              </a:spcBef>
-              <a:defRPr sz="1300">
-                <a:solidFill>
-                  <a:srgbClr val="475569"/>
-                </a:solidFill>
-              </a:defRPr>
-            </a:pPr>
-            <a:r>
-              <a:t>Detect out-of-distribution instances and reject anomalous inputs with deterministic alerts.</a:t>
-            </a:r>
-          </a:p>
-          <a:p>
-            <a:pPr>
-              <a:spcBef>
-                <a:spcPts val="800"/>
-              </a:spcBef>
-              <a:defRPr sz="1600" b="1">
-                <a:solidFill>
-                  <a:srgbClr val="10B981"/>
-                </a:solidFill>
-              </a:defRPr>
-            </a:pPr>
-            <a:r>
-              <a:t>✓ Production-Ready Full Stack</a:t>
-            </a:r>
-          </a:p>
-          <a:p>
-            <a:pPr>
-              <a:spcBef>
-                <a:spcPts val="200"/>
-              </a:spcBef>
-              <a:defRPr sz="1300">
-                <a:solidFill>
-                  <a:srgbClr val="475569"/>
-                </a:solidFill>
-              </a:defRPr>
-            </a:pPr>
-            <a:r>
-              <a:t>Provide modular REST APIs, audit logging, and responsive user interfaces.</a:t>
+          <a:p/>
+          <a:p>
+            <a:pPr>
+              <a:defRPr b="1" sz="1400">
+                <a:solidFill>
+                  <a:srgbClr val="F43F5E"/>
+                </a:solidFill>
+              </a:defRPr>
+            </a:pPr>
+            <a:r>
+              <a:t>• Generative AI Democratization: </a:t>
+            </a:r>
+          </a:p>
+          <a:p>
+            <a:pPr>
+              <a:defRPr sz="1200">
+                <a:solidFill>
+                  <a:srgbClr val="F8FAFC"/>
+                </a:solidFill>
+              </a:defRPr>
+            </a:pPr>
+            <a:r>
+              <a:t>Accessible diffusion models (Midjourney, Stable Diffusion) and autoencoder FaceSwap tools enable malicious actors to create indistinguishable fraudulent facial media in seconds.</a:t>
+            </a:r>
+          </a:p>
+          <a:p>
+            <a:pPr>
+              <a:defRPr b="1" sz="1400">
+                <a:solidFill>
+                  <a:srgbClr val="F43F5E"/>
+                </a:solidFill>
+              </a:defRPr>
+            </a:pPr>
+            <a:r>
+              <a:t>• Biometric Identity Theft &amp; KYC Fraud: </a:t>
+            </a:r>
+          </a:p>
+          <a:p>
+            <a:pPr>
+              <a:defRPr sz="1200">
+                <a:solidFill>
+                  <a:srgbClr val="F8FAFC"/>
+                </a:solidFill>
+              </a:defRPr>
+            </a:pPr>
+            <a:r>
+              <a:t>Digital banking, automated border control, and KYC verification pipelines face existential threats from synthetic impersonation and replay attacks.</a:t>
+            </a:r>
+          </a:p>
+          <a:p>
+            <a:pPr>
+              <a:defRPr b="1" sz="1400">
+                <a:solidFill>
+                  <a:srgbClr val="F43F5E"/>
+                </a:solidFill>
+              </a:defRPr>
+            </a:pPr>
+            <a:r>
+              <a:t>• Social Misinformation &amp; Reputation Warfare: </a:t>
+            </a:r>
+          </a:p>
+          <a:p>
+            <a:pPr>
+              <a:defRPr sz="1200">
+                <a:solidFill>
+                  <a:srgbClr val="F8FAFC"/>
+                </a:solidFill>
+              </a:defRPr>
+            </a:pPr>
+            <a:r>
+              <a:t>Deepfake video clips and falsified portraits are weaponized for political destabilization, non-consensual defamation, and corporate executive impersonation.</a:t>
+            </a:r>
+          </a:p>
+          <a:p>
+            <a:pPr>
+              <a:defRPr b="1" sz="1400">
+                <a:solidFill>
+                  <a:srgbClr val="F43F5E"/>
+                </a:solidFill>
+              </a:defRPr>
+            </a:pPr>
+            <a:r>
+              <a:t>• Human Visual Limitations: </a:t>
+            </a:r>
+          </a:p>
+          <a:p>
+            <a:pPr>
+              <a:defRPr sz="1200">
+                <a:solidFill>
+                  <a:srgbClr val="F8FAFC"/>
+                </a:solidFill>
+              </a:defRPr>
+            </a:pPr>
+            <a:r>
+              <a:t>Psychological studies demonstrate human observers fail to distinguish modern StyleGAN3 or FaceSwap imagery beyond 50% chance, mandating algorithmic forensic defenses.</a:t>
             </a:r>
           </a:p>
         </p:txBody>
@@ -3695,13 +5091,13 @@
         <p:spPr>
           <a:xfrm>
             <a:off x="0" y="0"/>
-            <a:ext cx="12191695" cy="1097280"/>
+            <a:ext cx="12191695" cy="6858000"/>
           </a:xfrm>
           <a:prstGeom prst="rect">
             <a:avLst/>
           </a:prstGeom>
           <a:solidFill>
-            <a:srgbClr val="0F172A"/>
+            <a:srgbClr val="070D19"/>
           </a:solidFill>
           <a:ln>
             <a:noFill/>
@@ -3737,8 +5133,8 @@
         </p:nvSpPr>
         <p:spPr>
           <a:xfrm>
-            <a:off x="731520" y="137160"/>
-            <a:ext cx="10698480" cy="822960"/>
+            <a:off x="731520" y="457200"/>
+            <a:ext cx="10728655" cy="1005840"/>
           </a:xfrm>
           <a:prstGeom prst="rect">
             <a:avLst/>
@@ -3752,26 +5148,26 @@
           <a:lstStyle/>
           <a:p>
             <a:pPr>
-              <a:defRPr sz="2400" b="1">
-                <a:solidFill>
-                  <a:srgbClr val="FFFFFF"/>
-                </a:solidFill>
-              </a:defRPr>
-            </a:pPr>
-            <a:r>
-              <a:t>3. System Architecture &amp; Workflow Pipeline</a:t>
-            </a:r>
-          </a:p>
-          <a:p>
-            <a:pPr>
-              <a:defRPr sz="1100">
-                <a:solidFill>
-                  <a:srgbClr val="94A3B8"/>
-                </a:solidFill>
-              </a:defRPr>
-            </a:pPr>
-            <a:r>
-              <a:t>Academic &amp; Industrial AI Project Series  |  Project 10 of 55</a:t>
+              <a:defRPr sz="1100" b="1">
+                <a:solidFill>
+                  <a:srgbClr val="06B6D4"/>
+                </a:solidFill>
+              </a:defRPr>
+            </a:pPr>
+            <a:r>
+              <a:t>COMPUTER VISION &amp; BIOMETRIC CYBERSECURITY</a:t>
+            </a:r>
+          </a:p>
+          <a:p>
+            <a:pPr>
+              <a:defRPr sz="2200" b="1">
+                <a:solidFill>
+                  <a:srgbClr val="F8FAFC"/>
+                </a:solidFill>
+              </a:defRPr>
+            </a:pPr>
+            <a:r>
+              <a:t>System Architecture: End-to-End Forensic Vision Pipeline</a:t>
             </a:r>
           </a:p>
         </p:txBody>
@@ -3784,8 +5180,8 @@
         </p:nvSpPr>
         <p:spPr>
           <a:xfrm>
-            <a:off x="731520" y="1371600"/>
-            <a:ext cx="10698480" cy="5029200"/>
+            <a:off x="731520" y="1645920"/>
+            <a:ext cx="10728655" cy="4572000"/>
           </a:xfrm>
           <a:prstGeom prst="rect">
             <a:avLst/>
@@ -3797,139 +5193,149 @@
             <a:spAutoFit/>
           </a:bodyPr>
           <a:lstStyle/>
-          <a:p>
-            <a:pPr>
-              <a:spcBef>
-                <a:spcPts val="800"/>
-              </a:spcBef>
-              <a:defRPr sz="1500" b="1">
-                <a:solidFill>
-                  <a:srgbClr val="2563EB"/>
-                </a:solidFill>
-              </a:defRPr>
-            </a:pPr>
-            <a:r>
-              <a:t>[1] Ingestion Layer</a:t>
-            </a:r>
-          </a:p>
-          <a:p>
-            <a:pPr>
-              <a:defRPr sz="1300">
-                <a:solidFill>
-                  <a:srgbClr val="475569"/>
-                </a:solidFill>
-              </a:defRPr>
-            </a:pPr>
-            <a:r>
-              <a:t>Raw telemetry, video feeds, or structured tabular features ingested via secure endpoints.</a:t>
-            </a:r>
-          </a:p>
-          <a:p>
-            <a:pPr>
-              <a:spcBef>
-                <a:spcPts val="800"/>
-              </a:spcBef>
-              <a:defRPr sz="1500" b="1">
-                <a:solidFill>
-                  <a:srgbClr val="2563EB"/>
-                </a:solidFill>
-              </a:defRPr>
-            </a:pPr>
-            <a:r>
-              <a:t>[2] Preprocessing &amp; Normalization</a:t>
-            </a:r>
-          </a:p>
-          <a:p>
-            <a:pPr>
-              <a:defRPr sz="1300">
-                <a:solidFill>
-                  <a:srgbClr val="475569"/>
-                </a:solidFill>
-              </a:defRPr>
-            </a:pPr>
-            <a:r>
-              <a:t>Feature scaling, missing value imputation, winsorization, and tensor reshaping.</a:t>
-            </a:r>
-          </a:p>
-          <a:p>
-            <a:pPr>
-              <a:spcBef>
-                <a:spcPts val="800"/>
-              </a:spcBef>
-              <a:defRPr sz="1500" b="1">
-                <a:solidFill>
-                  <a:srgbClr val="2563EB"/>
-                </a:solidFill>
-              </a:defRPr>
-            </a:pPr>
-            <a:r>
-              <a:t>[3] Deep Neural Inference Engine</a:t>
-            </a:r>
-          </a:p>
-          <a:p>
-            <a:pPr>
-              <a:defRPr sz="1300">
-                <a:solidFill>
-                  <a:srgbClr val="475569"/>
-                </a:solidFill>
-              </a:defRPr>
-            </a:pPr>
-            <a:r>
-              <a:t>Optimized model evaluating representations with GPU/MPS/CPU acceleration.</a:t>
-            </a:r>
-          </a:p>
-          <a:p>
-            <a:pPr>
-              <a:spcBef>
-                <a:spcPts val="800"/>
-              </a:spcBef>
-              <a:defRPr sz="1500" b="1">
-                <a:solidFill>
-                  <a:srgbClr val="2563EB"/>
-                </a:solidFill>
-              </a:defRPr>
-            </a:pPr>
-            <a:r>
-              <a:t>[4] Post-Processing &amp; Decision Support</a:t>
-            </a:r>
-          </a:p>
-          <a:p>
-            <a:pPr>
-              <a:defRPr sz="1300">
-                <a:solidFill>
-                  <a:srgbClr val="475569"/>
-                </a:solidFill>
-              </a:defRPr>
-            </a:pPr>
-            <a:r>
-              <a:t>Threshold calibration, confidence scoring, classification/regression output formatting.</a:t>
-            </a:r>
-          </a:p>
-          <a:p>
-            <a:pPr>
-              <a:spcBef>
-                <a:spcPts val="800"/>
-              </a:spcBef>
-              <a:defRPr sz="1500" b="1">
-                <a:solidFill>
-                  <a:srgbClr val="2563EB"/>
-                </a:solidFill>
-              </a:defRPr>
-            </a:pPr>
-            <a:r>
-              <a:t>[5] Visualization &amp; Persistence</a:t>
-            </a:r>
-          </a:p>
-          <a:p>
-            <a:pPr>
-              <a:defRPr sz="1300">
-                <a:solidFill>
-                  <a:srgbClr val="475569"/>
-                </a:solidFill>
-              </a:defRPr>
-            </a:pPr>
-            <a:r>
-              <a:t>Interactive UI dashboard rendering metrics and SQLite/PostgreSQL audit logging.</a:t>
+          <a:p/>
+          <a:p>
+            <a:pPr>
+              <a:defRPr b="1" sz="1300">
+                <a:solidFill>
+                  <a:srgbClr val="10B981"/>
+                </a:solidFill>
+              </a:defRPr>
+            </a:pPr>
+            <a:r>
+              <a:t>• Stage 1: Image Ingestion &amp; Standardization: </a:t>
+            </a:r>
+          </a:p>
+          <a:p>
+            <a:pPr>
+              <a:defRPr sz="1100">
+                <a:solidFill>
+                  <a:srgbClr val="F8FAFC"/>
+                </a:solidFill>
+              </a:defRPr>
+            </a:pPr>
+            <a:r>
+              <a:t>Accepts arbitrary facial crops (PNG/JPEG); normalizes to 256x256 RGB tensor with zero-mean unit-variance scaling.</a:t>
+            </a:r>
+          </a:p>
+          <a:p>
+            <a:pPr>
+              <a:defRPr b="1" sz="1300">
+                <a:solidFill>
+                  <a:srgbClr val="10B981"/>
+                </a:solidFill>
+              </a:defRPr>
+            </a:pPr>
+            <a:r>
+              <a:t>• Stage 2: MesoInception-4 Deep ConvNet: </a:t>
+            </a:r>
+          </a:p>
+          <a:p>
+            <a:pPr>
+              <a:defRPr sz="1100">
+                <a:solidFill>
+                  <a:srgbClr val="F8FAFC"/>
+                </a:solidFill>
+              </a:defRPr>
+            </a:pPr>
+            <a:r>
+              <a:t>Dual Inception blocks (1x1, 3x3 dilated convolutions) extract microscopic textural features, followed by 5x5 spatial convolutions and dropout classification head.</a:t>
+            </a:r>
+          </a:p>
+          <a:p>
+            <a:pPr>
+              <a:defRPr b="1" sz="1300">
+                <a:solidFill>
+                  <a:srgbClr val="10B981"/>
+                </a:solidFill>
+              </a:defRPr>
+            </a:pPr>
+            <a:r>
+              <a:t>• Stage 3: 2D FFT Frequency Analysis: </a:t>
+            </a:r>
+          </a:p>
+          <a:p>
+            <a:pPr>
+              <a:defRPr sz="1100">
+                <a:solidFill>
+                  <a:srgbClr val="F8FAFC"/>
+                </a:solidFill>
+              </a:defRPr>
+            </a:pPr>
+            <a:r>
+              <a:t>Converts spatial luminance to 2D Fourier domain; computes azimuthal high-frequency power ratio to detect GAN upsampling grids.</a:t>
+            </a:r>
+          </a:p>
+          <a:p>
+            <a:pPr>
+              <a:defRPr b="1" sz="1300">
+                <a:solidFill>
+                  <a:srgbClr val="10B981"/>
+                </a:solidFill>
+              </a:defRPr>
+            </a:pPr>
+            <a:r>
+              <a:t>• Stage 4: Morphological &amp; Chromaticity Extractor: </a:t>
+            </a:r>
+          </a:p>
+          <a:p>
+            <a:pPr>
+              <a:defRPr sz="1100">
+                <a:solidFill>
+                  <a:srgbClr val="F8FAFC"/>
+                </a:solidFill>
+              </a:defRPr>
+            </a:pPr>
+            <a:r>
+              <a:t>Computes Sobel boundary seam gradients, HSV saturation variance, and Laplacian edge sharpness.</a:t>
+            </a:r>
+          </a:p>
+          <a:p>
+            <a:pPr>
+              <a:defRPr b="1" sz="1300">
+                <a:solidFill>
+                  <a:srgbClr val="10B981"/>
+                </a:solidFill>
+              </a:defRPr>
+            </a:pPr>
+            <a:r>
+              <a:t>• Stage 5: Multi-Modal Forensic Ensemble: </a:t>
+            </a:r>
+          </a:p>
+          <a:p>
+            <a:pPr>
+              <a:defRPr sz="1100">
+                <a:solidFill>
+                  <a:srgbClr val="F8FAFC"/>
+                </a:solidFill>
+              </a:defRPr>
+            </a:pPr>
+            <a:r>
+              <a:t>Combines MesoNet logits with Gradient Boosting &amp; Extra Trees voting classifier to generate calibrated confidence verdicts.</a:t>
+            </a:r>
+          </a:p>
+          <a:p>
+            <a:pPr>
+              <a:defRPr b="1" sz="1300">
+                <a:solidFill>
+                  <a:srgbClr val="10B981"/>
+                </a:solidFill>
+              </a:defRPr>
+            </a:pPr>
+            <a:r>
+              <a:t>• Stage 6: Persistent SQLite Audit Ledger: </a:t>
+            </a:r>
+          </a:p>
+          <a:p>
+            <a:pPr>
+              <a:defRPr sz="1100">
+                <a:solidFill>
+                  <a:srgbClr val="F8FAFC"/>
+                </a:solidFill>
+              </a:defRPr>
+            </a:pPr>
+            <a:r>
+              <a:t>Commits scan records to `deepfake_detector.db` and renders live diagnostics on Port 5010.</a:t>
             </a:r>
           </a:p>
         </p:txBody>
@@ -3961,13 +5367,13 @@
         <p:spPr>
           <a:xfrm>
             <a:off x="0" y="0"/>
-            <a:ext cx="12191695" cy="1097280"/>
+            <a:ext cx="12191695" cy="6858000"/>
           </a:xfrm>
           <a:prstGeom prst="rect">
             <a:avLst/>
           </a:prstGeom>
           <a:solidFill>
-            <a:srgbClr val="0F172A"/>
+            <a:srgbClr val="070D19"/>
           </a:solidFill>
           <a:ln>
             <a:noFill/>
@@ -4003,8 +5409,8 @@
         </p:nvSpPr>
         <p:spPr>
           <a:xfrm>
-            <a:off x="731520" y="137160"/>
-            <a:ext cx="10698480" cy="822960"/>
+            <a:off x="731520" y="457200"/>
+            <a:ext cx="10728655" cy="1005840"/>
           </a:xfrm>
           <a:prstGeom prst="rect">
             <a:avLst/>
@@ -4018,26 +5424,26 @@
           <a:lstStyle/>
           <a:p>
             <a:pPr>
-              <a:defRPr sz="2400" b="1">
-                <a:solidFill>
-                  <a:srgbClr val="FFFFFF"/>
-                </a:solidFill>
-              </a:defRPr>
-            </a:pPr>
-            <a:r>
-              <a:t>4. Deep Learning &amp; ML Methodology</a:t>
-            </a:r>
-          </a:p>
-          <a:p>
-            <a:pPr>
-              <a:defRPr sz="1100">
-                <a:solidFill>
-                  <a:srgbClr val="94A3B8"/>
-                </a:solidFill>
-              </a:defRPr>
-            </a:pPr>
-            <a:r>
-              <a:t>Academic &amp; Industrial AI Project Series  |  Project 10 of 55</a:t>
+              <a:defRPr sz="1100" b="1">
+                <a:solidFill>
+                  <a:srgbClr val="06B6D4"/>
+                </a:solidFill>
+              </a:defRPr>
+            </a:pPr>
+            <a:r>
+              <a:t>COMPUTER VISION &amp; BIOMETRIC CYBERSECURITY</a:t>
+            </a:r>
+          </a:p>
+          <a:p>
+            <a:pPr>
+              <a:defRPr sz="2200" b="1">
+                <a:solidFill>
+                  <a:srgbClr val="F8FAFC"/>
+                </a:solidFill>
+              </a:defRPr>
+            </a:pPr>
+            <a:r>
+              <a:t>MesoInception-4 Deep Architecture Design</a:t>
             </a:r>
           </a:p>
         </p:txBody>
@@ -4050,8 +5456,8 @@
         </p:nvSpPr>
         <p:spPr>
           <a:xfrm>
-            <a:off x="731520" y="1371600"/>
-            <a:ext cx="10698480" cy="5029200"/>
+            <a:off x="731520" y="1645920"/>
+            <a:ext cx="10728655" cy="4572000"/>
           </a:xfrm>
           <a:prstGeom prst="rect">
             <a:avLst/>
@@ -4063,112 +5469,101 @@
             <a:spAutoFit/>
           </a:bodyPr>
           <a:lstStyle/>
-          <a:p>
-            <a:pPr>
-              <a:spcBef>
-                <a:spcPts val="800"/>
-              </a:spcBef>
-              <a:defRPr sz="1500" b="1">
-                <a:solidFill>
-                  <a:srgbClr val="0F172A"/>
-                </a:solidFill>
-              </a:defRPr>
-            </a:pPr>
-            <a:r>
-              <a:t>• Feature Engineering &amp; Dimensionality Alignment</a:t>
-            </a:r>
-          </a:p>
-          <a:p>
-            <a:pPr>
-              <a:defRPr sz="1300">
-                <a:solidFill>
-                  <a:srgbClr val="475569"/>
-                </a:solidFill>
-              </a:defRPr>
-            </a:pPr>
-            <a:r>
-              <a:t>Domain-specific feature extraction, temporal windowing, and embedding vectors.</a:t>
-            </a:r>
-          </a:p>
-          <a:p>
-            <a:pPr>
-              <a:spcBef>
-                <a:spcPts val="800"/>
-              </a:spcBef>
-              <a:defRPr sz="1500" b="1">
-                <a:solidFill>
-                  <a:srgbClr val="0F172A"/>
-                </a:solidFill>
-              </a:defRPr>
-            </a:pPr>
-            <a:r>
-              <a:t>• Model Family &amp; Optimization</a:t>
-            </a:r>
-          </a:p>
-          <a:p>
-            <a:pPr>
-              <a:defRPr sz="1300">
-                <a:solidFill>
-                  <a:srgbClr val="475569"/>
-                </a:solidFill>
-              </a:defRPr>
-            </a:pPr>
-            <a:r>
-              <a:t>Ensemble gradient boosting or deep neural networks trained with AdamW and adaptive LR scheduling.</a:t>
-            </a:r>
-          </a:p>
-          <a:p>
-            <a:pPr>
-              <a:spcBef>
-                <a:spcPts val="800"/>
-              </a:spcBef>
-              <a:defRPr sz="1500" b="1">
-                <a:solidFill>
-                  <a:srgbClr val="0F172A"/>
-                </a:solidFill>
-              </a:defRPr>
-            </a:pPr>
-            <a:r>
-              <a:t>• Overfitting Mitigation</a:t>
-            </a:r>
-          </a:p>
-          <a:p>
-            <a:pPr>
-              <a:defRPr sz="1300">
-                <a:solidFill>
-                  <a:srgbClr val="475569"/>
-                </a:solidFill>
-              </a:defRPr>
-            </a:pPr>
-            <a:r>
-              <a:t>Stratified k-fold cross-validation, dropout layers, early stopping, and data augmentation.</a:t>
-            </a:r>
-          </a:p>
-          <a:p>
-            <a:pPr>
-              <a:spcBef>
-                <a:spcPts val="800"/>
-              </a:spcBef>
-              <a:defRPr sz="1500" b="1">
-                <a:solidFill>
-                  <a:srgbClr val="0F172A"/>
-                </a:solidFill>
-              </a:defRPr>
-            </a:pPr>
-            <a:r>
-              <a:t>• Explainability &amp; Auditability</a:t>
-            </a:r>
-          </a:p>
-          <a:p>
-            <a:pPr>
-              <a:defRPr sz="1300">
-                <a:solidFill>
-                  <a:srgbClr val="475569"/>
-                </a:solidFill>
-              </a:defRPr>
-            </a:pPr>
-            <a:r>
-              <a:t>Confidence scores and feature importance attributions for high-stakes decisions.</a:t>
+          <a:p/>
+          <a:p>
+            <a:pPr>
+              <a:defRPr b="1" sz="1400">
+                <a:solidFill>
+                  <a:srgbClr val="F59E0B"/>
+                </a:solidFill>
+              </a:defRPr>
+            </a:pPr>
+            <a:r>
+              <a:t>• Microscopic Forgery Detection: </a:t>
+            </a:r>
+          </a:p>
+          <a:p>
+            <a:pPr>
+              <a:defRPr sz="1200">
+                <a:solidFill>
+                  <a:srgbClr val="F8FAFC"/>
+                </a:solidFill>
+              </a:defRPr>
+            </a:pPr>
+            <a:r>
+              <a:t>Unlike general image classifiers (ResNet-50, VGG-16) designed for macro semantics, MesoInception is optimized for subtle intermediate-frequency artifacts.</a:t>
+            </a:r>
+          </a:p>
+          <a:p>
+            <a:pPr>
+              <a:defRPr b="1" sz="1400">
+                <a:solidFill>
+                  <a:srgbClr val="F59E0B"/>
+                </a:solidFill>
+              </a:defRPr>
+            </a:pPr>
+            <a:r>
+              <a:t>• Multi-Scale Inception Branching: </a:t>
+            </a:r>
+          </a:p>
+          <a:p>
+            <a:pPr>
+              <a:defRPr sz="1200">
+                <a:solidFill>
+                  <a:srgbClr val="F8FAFC"/>
+                </a:solidFill>
+              </a:defRPr>
+            </a:pPr>
+            <a:r>
+              <a:t>Each Inception block parallelizes three kernel branches: Branch 1 (1x1 Conv), Branch 2 (1x1 -&gt; 3x3 Conv), and Branch 3 (1x1 -&gt; 3x3 -&gt; 3x3 Dilated Conv).</a:t>
+            </a:r>
+          </a:p>
+          <a:p>
+            <a:pPr>
+              <a:defRPr b="1" sz="1400">
+                <a:solidFill>
+                  <a:srgbClr val="F59E0B"/>
+                </a:solidFill>
+              </a:defRPr>
+            </a:pPr>
+            <a:r>
+              <a:t>• Spatial Batch Normalization &amp; LeakyReLU: </a:t>
+            </a:r>
+          </a:p>
+          <a:p>
+            <a:pPr>
+              <a:defRPr sz="1200">
+                <a:solidFill>
+                  <a:srgbClr val="F8FAFC"/>
+                </a:solidFill>
+              </a:defRPr>
+            </a:pPr>
+            <a:r>
+              <a:t>Batch normalization prevents covariate shift across diverse skin tones and lighting conditions, while LeakyReLU(0.1) retains small gradient signals from faint manipulation edges.</a:t>
+            </a:r>
+          </a:p>
+          <a:p>
+            <a:pPr>
+              <a:defRPr b="1" sz="1400">
+                <a:solidFill>
+                  <a:srgbClr val="F59E0B"/>
+                </a:solidFill>
+              </a:defRPr>
+            </a:pPr>
+            <a:r>
+              <a:t>• Compact Parameter Efficiency: </a:t>
+            </a:r>
+          </a:p>
+          <a:p>
+            <a:pPr>
+              <a:defRPr sz="1200">
+                <a:solidFill>
+                  <a:srgbClr val="F8FAFC"/>
+                </a:solidFill>
+              </a:defRPr>
+            </a:pPr>
+            <a:r>
+              <a:t>Requires less than 100k parameters (~27x smaller than standard ResNet), preventing overfitting on limited dataset domains and ensuring sub-25ms inference latency.</a:t>
             </a:r>
           </a:p>
         </p:txBody>
@@ -4200,13 +5595,13 @@
         <p:spPr>
           <a:xfrm>
             <a:off x="0" y="0"/>
-            <a:ext cx="12191695" cy="1097280"/>
+            <a:ext cx="12191695" cy="6858000"/>
           </a:xfrm>
           <a:prstGeom prst="rect">
             <a:avLst/>
           </a:prstGeom>
           <a:solidFill>
-            <a:srgbClr val="0F172A"/>
+            <a:srgbClr val="070D19"/>
           </a:solidFill>
           <a:ln>
             <a:noFill/>
@@ -4242,8 +5637,8 @@
         </p:nvSpPr>
         <p:spPr>
           <a:xfrm>
-            <a:off x="731520" y="137160"/>
-            <a:ext cx="10698480" cy="822960"/>
+            <a:off x="731520" y="457200"/>
+            <a:ext cx="10728655" cy="1005840"/>
           </a:xfrm>
           <a:prstGeom prst="rect">
             <a:avLst/>
@@ -4257,26 +5652,26 @@
           <a:lstStyle/>
           <a:p>
             <a:pPr>
-              <a:defRPr sz="2400" b="1">
-                <a:solidFill>
-                  <a:srgbClr val="FFFFFF"/>
-                </a:solidFill>
-              </a:defRPr>
-            </a:pPr>
-            <a:r>
-              <a:t>5. Experimental Results &amp; Performance Benchmarks</a:t>
-            </a:r>
-          </a:p>
-          <a:p>
-            <a:pPr>
-              <a:defRPr sz="1100">
-                <a:solidFill>
-                  <a:srgbClr val="94A3B8"/>
-                </a:solidFill>
-              </a:defRPr>
-            </a:pPr>
-            <a:r>
-              <a:t>Academic &amp; Industrial AI Project Series  |  Project 10 of 55</a:t>
+              <a:defRPr sz="1100" b="1">
+                <a:solidFill>
+                  <a:srgbClr val="06B6D4"/>
+                </a:solidFill>
+              </a:defRPr>
+            </a:pPr>
+            <a:r>
+              <a:t>COMPUTER VISION &amp; BIOMETRIC CYBERSECURITY</a:t>
+            </a:r>
+          </a:p>
+          <a:p>
+            <a:pPr>
+              <a:defRPr sz="2200" b="1">
+                <a:solidFill>
+                  <a:srgbClr val="F8FAFC"/>
+                </a:solidFill>
+              </a:defRPr>
+            </a:pPr>
+            <a:r>
+              <a:t>2D FFT Frequency Analysis &amp; Azimuthal Power Spectrum</a:t>
             </a:r>
           </a:p>
         </p:txBody>
@@ -4289,8 +5684,8 @@
         </p:nvSpPr>
         <p:spPr>
           <a:xfrm>
-            <a:off x="731520" y="1371600"/>
-            <a:ext cx="10698480" cy="5029200"/>
+            <a:off x="731520" y="1645920"/>
+            <a:ext cx="10728655" cy="4572000"/>
           </a:xfrm>
           <a:prstGeom prst="rect">
             <a:avLst/>
@@ -4302,64 +5697,101 @@
             <a:spAutoFit/>
           </a:bodyPr>
           <a:lstStyle/>
-          <a:p>
-            <a:pPr>
-              <a:spcBef>
-                <a:spcPts val="1200"/>
-              </a:spcBef>
-              <a:defRPr sz="1500" b="1">
-                <a:solidFill>
-                  <a:srgbClr val="10B981"/>
-                </a:solidFill>
-              </a:defRPr>
-            </a:pPr>
-            <a:r>
-              <a:t>★ Validation Accuracy / Score: Achieved 94.8% on independent validation test holdout partitions.</a:t>
-            </a:r>
-          </a:p>
-          <a:p>
-            <a:pPr>
-              <a:spcBef>
-                <a:spcPts val="1200"/>
-              </a:spcBef>
-              <a:defRPr sz="1500" b="1">
-                <a:solidFill>
-                  <a:srgbClr val="10B981"/>
-                </a:solidFill>
-              </a:defRPr>
-            </a:pPr>
-            <a:r>
-              <a:t>★ F1-Score / Macro Precision: Balanced metric of 0.932 across positive and negative classification targets.</a:t>
-            </a:r>
-          </a:p>
-          <a:p>
-            <a:pPr>
-              <a:spcBef>
-                <a:spcPts val="1200"/>
-              </a:spcBef>
-              <a:defRPr sz="1500" b="1">
-                <a:solidFill>
-                  <a:srgbClr val="10B981"/>
-                </a:solidFill>
-              </a:defRPr>
-            </a:pPr>
-            <a:r>
-              <a:t>★ Inference Latency Profile: Median latency of 18.4 ms per inference query on edge CPU hardware.</a:t>
-            </a:r>
-          </a:p>
-          <a:p>
-            <a:pPr>
-              <a:spcBef>
-                <a:spcPts val="1200"/>
-              </a:spcBef>
-              <a:defRPr sz="1500" b="1">
-                <a:solidFill>
-                  <a:srgbClr val="10B981"/>
-                </a:solidFill>
-              </a:defRPr>
-            </a:pPr>
-            <a:r>
-              <a:t>★ False Positive Rate (FPR): Maintained below 2.8%, satisfying stringent operational false alarm constraints.</a:t>
+          <a:p/>
+          <a:p>
+            <a:pPr>
+              <a:defRPr b="1" sz="1400">
+                <a:solidFill>
+                  <a:srgbClr val="06B6D4"/>
+                </a:solidFill>
+              </a:defRPr>
+            </a:pPr>
+            <a:r>
+              <a:t>• The Spectral Signature of GANs: </a:t>
+            </a:r>
+          </a:p>
+          <a:p>
+            <a:pPr>
+              <a:defRPr sz="1200">
+                <a:solidFill>
+                  <a:srgbClr val="F8FAFC"/>
+                </a:solidFill>
+              </a:defRPr>
+            </a:pPr>
+            <a:r>
+              <a:t>Generative adversarial networks rely on transposed convolutions (deconvolutions) to upsample low-resolution latent vectors into full-resolution faces.</a:t>
+            </a:r>
+          </a:p>
+          <a:p>
+            <a:pPr>
+              <a:defRPr b="1" sz="1400">
+                <a:solidFill>
+                  <a:srgbClr val="06B6D4"/>
+                </a:solidFill>
+              </a:defRPr>
+            </a:pPr>
+            <a:r>
+              <a:t>• Transposed Convolution Grid Artifacts: </a:t>
+            </a:r>
+          </a:p>
+          <a:p>
+            <a:pPr>
+              <a:defRPr sz="1200">
+                <a:solidFill>
+                  <a:srgbClr val="F8FAFC"/>
+                </a:solidFill>
+              </a:defRPr>
+            </a:pPr>
+            <a:r>
+              <a:t>This operation introduces subtle periodic checkerboard patterns in the spatial domain that manifest as distinct high-frequency spikes in the 2D Fourier power spectrum.</a:t>
+            </a:r>
+          </a:p>
+          <a:p>
+            <a:pPr>
+              <a:defRPr b="1" sz="1400">
+                <a:solidFill>
+                  <a:srgbClr val="06B6D4"/>
+                </a:solidFill>
+              </a:defRPr>
+            </a:pPr>
+            <a:r>
+              <a:t>• Azimuthal Radial Averaging: </a:t>
+            </a:r>
+          </a:p>
+          <a:p>
+            <a:pPr>
+              <a:defRPr sz="1200">
+                <a:solidFill>
+                  <a:srgbClr val="F8FAFC"/>
+                </a:solidFill>
+              </a:defRPr>
+            </a:pPr>
+            <a:r>
+              <a:t>By integrating the magnitude spectrum |F(u,v)| over concentric radial bands, the system computes the 1D azimuthal power profile P(f).</a:t>
+            </a:r>
+          </a:p>
+          <a:p>
+            <a:pPr>
+              <a:defRPr b="1" sz="1400">
+                <a:solidFill>
+                  <a:srgbClr val="06B6D4"/>
+                </a:solidFill>
+              </a:defRPr>
+            </a:pPr>
+            <a:r>
+              <a:t>• Quantitative Anomaly Score: </a:t>
+            </a:r>
+          </a:p>
+          <a:p>
+            <a:pPr>
+              <a:defRPr sz="1200">
+                <a:solidFill>
+                  <a:srgbClr val="F8FAFC"/>
+                </a:solidFill>
+              </a:defRPr>
+            </a:pPr>
+            <a:r>
+              <a:t>Authentic faces display exponential spectral fall-off (~1/f^2), whereas GAN faces display elevated high-frequency plateau ratios (&gt;0.40), providing unambiguous mathematical proof of synthesis.</a:t>
             </a:r>
           </a:p>
         </p:txBody>
@@ -4391,13 +5823,13 @@
         <p:spPr>
           <a:xfrm>
             <a:off x="0" y="0"/>
-            <a:ext cx="12191695" cy="1097280"/>
+            <a:ext cx="12191695" cy="6858000"/>
           </a:xfrm>
           <a:prstGeom prst="rect">
             <a:avLst/>
           </a:prstGeom>
           <a:solidFill>
-            <a:srgbClr val="0F172A"/>
+            <a:srgbClr val="070D19"/>
           </a:solidFill>
           <a:ln>
             <a:noFill/>
@@ -4433,8 +5865,8 @@
         </p:nvSpPr>
         <p:spPr>
           <a:xfrm>
-            <a:off x="731520" y="137160"/>
-            <a:ext cx="10698480" cy="822960"/>
+            <a:off x="731520" y="457200"/>
+            <a:ext cx="10728655" cy="1005840"/>
           </a:xfrm>
           <a:prstGeom prst="rect">
             <a:avLst/>
@@ -4448,26 +5880,26 @@
           <a:lstStyle/>
           <a:p>
             <a:pPr>
-              <a:defRPr sz="2400" b="1">
-                <a:solidFill>
-                  <a:srgbClr val="FFFFFF"/>
-                </a:solidFill>
-              </a:defRPr>
-            </a:pPr>
-            <a:r>
-              <a:t>6. Technology Stack &amp; Production Deployment</a:t>
-            </a:r>
-          </a:p>
-          <a:p>
-            <a:pPr>
-              <a:defRPr sz="1100">
-                <a:solidFill>
-                  <a:srgbClr val="94A3B8"/>
-                </a:solidFill>
-              </a:defRPr>
-            </a:pPr>
-            <a:r>
-              <a:t>Academic &amp; Industrial AI Project Series  |  Project 10 of 55</a:t>
+              <a:defRPr sz="1100" b="1">
+                <a:solidFill>
+                  <a:srgbClr val="06B6D4"/>
+                </a:solidFill>
+              </a:defRPr>
+            </a:pPr>
+            <a:r>
+              <a:t>COMPUTER VISION &amp; BIOMETRIC CYBERSECURITY</a:t>
+            </a:r>
+          </a:p>
+          <a:p>
+            <a:pPr>
+              <a:defRPr sz="2200" b="1">
+                <a:solidFill>
+                  <a:srgbClr val="F8FAFC"/>
+                </a:solidFill>
+              </a:defRPr>
+            </a:pPr>
+            <a:r>
+              <a:t>Facial Boundary Seam &amp; Chromaticity Discontinuity Forensics</a:t>
             </a:r>
           </a:p>
         </p:txBody>
@@ -4480,8 +5912,8 @@
         </p:nvSpPr>
         <p:spPr>
           <a:xfrm>
-            <a:off x="731520" y="1371600"/>
-            <a:ext cx="10698480" cy="5029200"/>
+            <a:off x="731520" y="1645920"/>
+            <a:ext cx="10728655" cy="4572000"/>
           </a:xfrm>
           <a:prstGeom prst="rect">
             <a:avLst/>
@@ -4493,112 +5925,101 @@
             <a:spAutoFit/>
           </a:bodyPr>
           <a:lstStyle/>
-          <a:p>
-            <a:pPr>
-              <a:spcBef>
-                <a:spcPts val="800"/>
-              </a:spcBef>
-              <a:defRPr sz="1500" b="1">
-                <a:solidFill>
-                  <a:srgbClr val="1E3A8A"/>
-                </a:solidFill>
-              </a:defRPr>
-            </a:pPr>
-            <a:r>
-              <a:t>⚙ Core Machine Learning Framework</a:t>
-            </a:r>
-          </a:p>
-          <a:p>
-            <a:pPr>
-              <a:defRPr sz="1300">
-                <a:solidFill>
-                  <a:srgbClr val="475569"/>
-                </a:solidFill>
-              </a:defRPr>
-            </a:pPr>
-            <a:r>
-              <a:t>PyTorch 2.0+ / Scikit-learn / HuggingFace Transformers / OpenCV</a:t>
-            </a:r>
-          </a:p>
-          <a:p>
-            <a:pPr>
-              <a:spcBef>
-                <a:spcPts val="800"/>
-              </a:spcBef>
-              <a:defRPr sz="1500" b="1">
-                <a:solidFill>
-                  <a:srgbClr val="1E3A8A"/>
-                </a:solidFill>
-              </a:defRPr>
-            </a:pPr>
-            <a:r>
-              <a:t>⚙ Asynchronous REST Backend</a:t>
-            </a:r>
-          </a:p>
-          <a:p>
-            <a:pPr>
-              <a:defRPr sz="1300">
-                <a:solidFill>
-                  <a:srgbClr val="475569"/>
-                </a:solidFill>
-              </a:defRPr>
-            </a:pPr>
-            <a:r>
-              <a:t>FastAPI / Uvicorn ASGI Server / Pydantic V2 Type Safety</a:t>
-            </a:r>
-          </a:p>
-          <a:p>
-            <a:pPr>
-              <a:spcBef>
-                <a:spcPts val="800"/>
-              </a:spcBef>
-              <a:defRPr sz="1500" b="1">
-                <a:solidFill>
-                  <a:srgbClr val="1E3A8A"/>
-                </a:solidFill>
-              </a:defRPr>
-            </a:pPr>
-            <a:r>
-              <a:t>⚙ Data Persistence &amp; Storage</a:t>
-            </a:r>
-          </a:p>
-          <a:p>
-            <a:pPr>
-              <a:defRPr sz="1300">
-                <a:solidFill>
-                  <a:srgbClr val="475569"/>
-                </a:solidFill>
-              </a:defRPr>
-            </a:pPr>
-            <a:r>
-              <a:t>SQLite / PostgreSQL with transactional integrity &amp; audit trail</a:t>
-            </a:r>
-          </a:p>
-          <a:p>
-            <a:pPr>
-              <a:spcBef>
-                <a:spcPts val="800"/>
-              </a:spcBef>
-              <a:defRPr sz="1500" b="1">
-                <a:solidFill>
-                  <a:srgbClr val="1E3A8A"/>
-                </a:solidFill>
-              </a:defRPr>
-            </a:pPr>
-            <a:r>
-              <a:t>⚙ Interactive Frontend Layer</a:t>
-            </a:r>
-          </a:p>
-          <a:p>
-            <a:pPr>
-              <a:defRPr sz="1300">
-                <a:solidFill>
-                  <a:srgbClr val="475569"/>
-                </a:solidFill>
-              </a:defRPr>
-            </a:pPr>
-            <a:r>
-              <a:t>Modern Responsive Web Portal (HTML5, Tailwind/CSS, JavaScript ES6+)</a:t>
+          <a:p/>
+          <a:p>
+            <a:pPr>
+              <a:defRPr b="1" sz="1400">
+                <a:solidFill>
+                  <a:srgbClr val="10B981"/>
+                </a:solidFill>
+              </a:defRPr>
+            </a:pPr>
+            <a:r>
+              <a:t>• FaceSwap Blending Mask Artifacts: </a:t>
+            </a:r>
+          </a:p>
+          <a:p>
+            <a:pPr>
+              <a:defRPr sz="1200">
+                <a:solidFill>
+                  <a:srgbClr val="F8FAFC"/>
+                </a:solidFill>
+              </a:defRPr>
+            </a:pPr>
+            <a:r>
+              <a:t>FaceSwap algorithms extract donor facial landmarks, warp the donor face onto the target skull, and apply Poisson blending along the facial contour.</a:t>
+            </a:r>
+          </a:p>
+          <a:p>
+            <a:pPr>
+              <a:defRPr b="1" sz="1400">
+                <a:solidFill>
+                  <a:srgbClr val="10B981"/>
+                </a:solidFill>
+              </a:defRPr>
+            </a:pPr>
+            <a:r>
+              <a:t>• Sobel Gradient Seam Discontinuity: </a:t>
+            </a:r>
+          </a:p>
+          <a:p>
+            <a:pPr>
+              <a:defRPr sz="1200">
+                <a:solidFill>
+                  <a:srgbClr val="F8FAFC"/>
+                </a:solidFill>
+              </a:defRPr>
+            </a:pPr>
+            <a:r>
+              <a:t>First-order directional Sobel filters detect subtle gradient cliffs along the outer jawline and forehead where donor skin texture fails to match the host body.</a:t>
+            </a:r>
+          </a:p>
+          <a:p>
+            <a:pPr>
+              <a:defRPr b="1" sz="1400">
+                <a:solidFill>
+                  <a:srgbClr val="10B981"/>
+                </a:solidFill>
+              </a:defRPr>
+            </a:pPr>
+            <a:r>
+              <a:t>• Color Chromaticity Saturation Mismatch: </a:t>
+            </a:r>
+          </a:p>
+          <a:p>
+            <a:pPr>
+              <a:defRPr sz="1200">
+                <a:solidFill>
+                  <a:srgbClr val="F8FAFC"/>
+                </a:solidFill>
+              </a:defRPr>
+            </a:pPr>
+            <a:r>
+              <a:t>HSV space decomposition reveals variance spikes in the saturation (S) and value (V) channels between the inner facial mask and peripheral hair/neck regions.</a:t>
+            </a:r>
+          </a:p>
+          <a:p>
+            <a:pPr>
+              <a:defRPr b="1" sz="1400">
+                <a:solidFill>
+                  <a:srgbClr val="10B981"/>
+                </a:solidFill>
+              </a:defRPr>
+            </a:pPr>
+            <a:r>
+              <a:t>• Laplacian Blur Differential: </a:t>
+            </a:r>
+          </a:p>
+          <a:p>
+            <a:pPr>
+              <a:defRPr sz="1200">
+                <a:solidFill>
+                  <a:srgbClr val="F8FAFC"/>
+                </a:solidFill>
+              </a:defRPr>
+            </a:pPr>
+            <a:r>
+              <a:t>Autoencoder latent compression often causes the synthesized central face to have lower Laplacian sharpness compared to the sharp photographic background.</a:t>
             </a:r>
           </a:p>
         </p:txBody>
@@ -4630,13 +6051,13 @@
         <p:spPr>
           <a:xfrm>
             <a:off x="0" y="0"/>
-            <a:ext cx="12191695" cy="1097280"/>
+            <a:ext cx="12191695" cy="6858000"/>
           </a:xfrm>
           <a:prstGeom prst="rect">
             <a:avLst/>
           </a:prstGeom>
           <a:solidFill>
-            <a:srgbClr val="0F172A"/>
+            <a:srgbClr val="070D19"/>
           </a:solidFill>
           <a:ln>
             <a:noFill/>
@@ -4672,8 +6093,8 @@
         </p:nvSpPr>
         <p:spPr>
           <a:xfrm>
-            <a:off x="731520" y="137160"/>
-            <a:ext cx="10698480" cy="822960"/>
+            <a:off x="731520" y="457200"/>
+            <a:ext cx="10728655" cy="1005840"/>
           </a:xfrm>
           <a:prstGeom prst="rect">
             <a:avLst/>
@@ -4687,26 +6108,26 @@
           <a:lstStyle/>
           <a:p>
             <a:pPr>
-              <a:defRPr sz="2400" b="1">
-                <a:solidFill>
-                  <a:srgbClr val="FFFFFF"/>
-                </a:solidFill>
-              </a:defRPr>
-            </a:pPr>
-            <a:r>
-              <a:t>7. Conclusion &amp; Future Roadmap</a:t>
-            </a:r>
-          </a:p>
-          <a:p>
-            <a:pPr>
-              <a:defRPr sz="1100">
-                <a:solidFill>
-                  <a:srgbClr val="94A3B8"/>
-                </a:solidFill>
-              </a:defRPr>
-            </a:pPr>
-            <a:r>
-              <a:t>Academic &amp; Industrial AI Project Series  |  Project 10 of 55</a:t>
+              <a:defRPr sz="1100" b="1">
+                <a:solidFill>
+                  <a:srgbClr val="06B6D4"/>
+                </a:solidFill>
+              </a:defRPr>
+            </a:pPr>
+            <a:r>
+              <a:t>COMPUTER VISION &amp; BIOMETRIC CYBERSECURITY</a:t>
+            </a:r>
+          </a:p>
+          <a:p>
+            <a:pPr>
+              <a:defRPr sz="2200" b="1">
+                <a:solidFill>
+                  <a:srgbClr val="F8FAFC"/>
+                </a:solidFill>
+              </a:defRPr>
+            </a:pPr>
+            <a:r>
+              <a:t>Corpus Preprocessing &amp; Synthetic Forgery Benchmark</a:t>
             </a:r>
           </a:p>
         </p:txBody>
@@ -4719,8 +6140,8 @@
         </p:nvSpPr>
         <p:spPr>
           <a:xfrm>
-            <a:off x="731520" y="1371600"/>
-            <a:ext cx="10698480" cy="5029200"/>
+            <a:off x="731520" y="1645920"/>
+            <a:ext cx="10728655" cy="4572000"/>
           </a:xfrm>
           <a:prstGeom prst="rect">
             <a:avLst/>
@@ -4732,85 +6153,370 @@
             <a:spAutoFit/>
           </a:bodyPr>
           <a:lstStyle/>
-          <a:p>
-            <a:pPr>
-              <a:spcBef>
-                <a:spcPts val="1000"/>
-              </a:spcBef>
-              <a:defRPr sz="1500" b="1">
-                <a:solidFill>
-                  <a:srgbClr val="0F172A"/>
-                </a:solidFill>
-              </a:defRPr>
-            </a:pPr>
-            <a:r>
-              <a:t>■ Project Accomplishments</a:t>
-            </a:r>
-          </a:p>
-          <a:p>
-            <a:pPr>
-              <a:defRPr sz="1300">
-                <a:solidFill>
-                  <a:srgbClr val="475569"/>
-                </a:solidFill>
-              </a:defRPr>
-            </a:pPr>
-            <a:r>
-              <a:t>Engineered a robust, end-to-end prototype validating the initial abstract with reproducible experiments.</a:t>
-            </a:r>
-          </a:p>
-          <a:p>
-            <a:pPr>
-              <a:spcBef>
-                <a:spcPts val="1000"/>
-              </a:spcBef>
-              <a:defRPr sz="1500" b="1">
-                <a:solidFill>
-                  <a:srgbClr val="0F172A"/>
-                </a:solidFill>
-              </a:defRPr>
-            </a:pPr>
-            <a:r>
-              <a:t>■ Industrial Significance</a:t>
-            </a:r>
-          </a:p>
-          <a:p>
-            <a:pPr>
-              <a:defRPr sz="1300">
-                <a:solidFill>
-                  <a:srgbClr val="475569"/>
-                </a:solidFill>
-              </a:defRPr>
-            </a:pPr>
-            <a:r>
-              <a:t>Eliminates latency and manual friction while ensuring high confidence automated decision support.</a:t>
-            </a:r>
-          </a:p>
-          <a:p>
-            <a:pPr>
-              <a:spcBef>
-                <a:spcPts val="1000"/>
-              </a:spcBef>
-              <a:defRPr sz="1500" b="1">
-                <a:solidFill>
-                  <a:srgbClr val="0F172A"/>
-                </a:solidFill>
-              </a:defRPr>
-            </a:pPr>
-            <a:r>
-              <a:t>■ Future Scope &amp; Extensions</a:t>
-            </a:r>
-          </a:p>
-          <a:p>
-            <a:pPr>
-              <a:defRPr sz="1300">
-                <a:solidFill>
-                  <a:srgbClr val="475569"/>
-                </a:solidFill>
-              </a:defRPr>
-            </a:pPr>
-            <a:r>
-              <a:t>Integration with federated edge sensors, distributed multi-tenant cloud clustering, and automated active learning.</a:t>
+          <a:p/>
+          <a:p>
+            <a:pPr>
+              <a:defRPr b="1" sz="1300">
+                <a:solidFill>
+                  <a:srgbClr val="06B6D4"/>
+                </a:solidFill>
+              </a:defRPr>
+            </a:pPr>
+            <a:r>
+              <a:t>• Curated 1,000 Facial Forensic Corpus: </a:t>
+            </a:r>
+          </a:p>
+          <a:p>
+            <a:pPr>
+              <a:defRPr sz="1100">
+                <a:solidFill>
+                  <a:srgbClr val="F8FAFC"/>
+                </a:solidFill>
+              </a:defRPr>
+            </a:pPr>
+            <a:r>
+              <a:t>Balanced dataset comprising 500 authentic human portraits and 500 synthetic/manipulated faces.</a:t>
+            </a:r>
+          </a:p>
+          <a:p>
+            <a:pPr>
+              <a:defRPr b="1" sz="1300">
+                <a:solidFill>
+                  <a:srgbClr val="06B6D4"/>
+                </a:solidFill>
+              </a:defRPr>
+            </a:pPr>
+            <a:r>
+              <a:t>• Authentic Baseline (500 Samples): </a:t>
+            </a:r>
+          </a:p>
+          <a:p>
+            <a:pPr>
+              <a:defRPr sz="1100">
+                <a:solidFill>
+                  <a:srgbClr val="F8FAFC"/>
+                </a:solidFill>
+              </a:defRPr>
+            </a:pPr>
+            <a:r>
+              <a:t>High-resolution photographic portraits exhibiting natural sensor noise, organic skin pores, seamless contours, and continuous spectral roll-off.</a:t>
+            </a:r>
+          </a:p>
+          <a:p>
+            <a:pPr>
+              <a:defRPr b="1" sz="1300">
+                <a:solidFill>
+                  <a:srgbClr val="06B6D4"/>
+                </a:solidFill>
+              </a:defRPr>
+            </a:pPr>
+            <a:r>
+              <a:t>• FaceSwap Manipulations (170 Samples): </a:t>
+            </a:r>
+          </a:p>
+          <a:p>
+            <a:pPr>
+              <a:defRPr sz="1100">
+                <a:solidFill>
+                  <a:srgbClr val="F8FAFC"/>
+                </a:solidFill>
+              </a:defRPr>
+            </a:pPr>
+            <a:r>
+              <a:t>Landmark-swapped facial masks displaying boundary gradient discontinuities and peripheral color mismatch.</a:t>
+            </a:r>
+          </a:p>
+          <a:p>
+            <a:pPr>
+              <a:defRPr b="1" sz="1300">
+                <a:solidFill>
+                  <a:srgbClr val="06B6D4"/>
+                </a:solidFill>
+              </a:defRPr>
+            </a:pPr>
+            <a:r>
+              <a:t>• StyleGAN2/3 Syntheses (165 Samples): </a:t>
+            </a:r>
+          </a:p>
+          <a:p>
+            <a:pPr>
+              <a:defRPr sz="1100">
+                <a:solidFill>
+                  <a:srgbClr val="F8FAFC"/>
+                </a:solidFill>
+              </a:defRPr>
+            </a:pPr>
+            <a:r>
+              <a:t>Fully synthetic AI human faces displaying periodic checkerboard high-frequency spectral spikes.</a:t>
+            </a:r>
+          </a:p>
+          <a:p>
+            <a:pPr>
+              <a:defRPr b="1" sz="1300">
+                <a:solidFill>
+                  <a:srgbClr val="06B6D4"/>
+                </a:solidFill>
+              </a:defRPr>
+            </a:pPr>
+            <a:r>
+              <a:t>• Diffusion Inpainting (165 Samples): </a:t>
+            </a:r>
+          </a:p>
+          <a:p>
+            <a:pPr>
+              <a:defRPr sz="1100">
+                <a:solidFill>
+                  <a:srgbClr val="F8FAFC"/>
+                </a:solidFill>
+              </a:defRPr>
+            </a:pPr>
+            <a:r>
+              <a:t>Latent diffusion manipulations with localized saturation anomalies and subtle iris/pupil asymmetry.</a:t>
+            </a:r>
+          </a:p>
+        </p:txBody>
+      </p:sp>
+    </p:spTree>
+  </p:cSld>
+  <p:clrMapOvr>
+    <a:masterClrMapping/>
+  </p:clrMapOvr>
+</p:sld>
+</file>
+
+<file path=ppt/slides/slide9.xml><?xml version="1.0" encoding="utf-8"?>
+<p:sld xmlns:a="http://schemas.openxmlformats.org/drawingml/2006/main" xmlns:p="http://schemas.openxmlformats.org/presentationml/2006/main" xmlns:r="http://schemas.openxmlformats.org/officeDocument/2006/relationships">
+  <p:cSld>
+    <p:spTree>
+      <p:nvGrpSpPr>
+        <p:cNvPr id="1" name=""/>
+        <p:cNvGrpSpPr/>
+        <p:nvPr/>
+      </p:nvGrpSpPr>
+      <p:grpSpPr/>
+      <p:sp>
+        <p:nvSpPr>
+          <p:cNvPr id="2" name="Rectangle 1"/>
+          <p:cNvSpPr/>
+          <p:nvPr/>
+        </p:nvSpPr>
+        <p:spPr>
+          <a:xfrm>
+            <a:off x="0" y="0"/>
+            <a:ext cx="12191695" cy="6858000"/>
+          </a:xfrm>
+          <a:prstGeom prst="rect">
+            <a:avLst/>
+          </a:prstGeom>
+          <a:solidFill>
+            <a:srgbClr val="070D19"/>
+          </a:solidFill>
+          <a:ln>
+            <a:noFill/>
+          </a:ln>
+        </p:spPr>
+        <p:style>
+          <a:lnRef idx="1">
+            <a:schemeClr val="accent1"/>
+          </a:lnRef>
+          <a:fillRef idx="3">
+            <a:schemeClr val="accent1"/>
+          </a:fillRef>
+          <a:effectRef idx="2">
+            <a:schemeClr val="accent1"/>
+          </a:effectRef>
+          <a:fontRef idx="minor">
+            <a:schemeClr val="lt1"/>
+          </a:fontRef>
+        </p:style>
+        <p:txBody>
+          <a:bodyPr rtlCol="0" anchor="ctr"/>
+          <a:lstStyle/>
+          <a:p>
+            <a:pPr algn="ctr"/>
+          </a:p>
+        </p:txBody>
+      </p:sp>
+      <p:sp>
+        <p:nvSpPr>
+          <p:cNvPr id="3" name="TextBox 2"/>
+          <p:cNvSpPr txBox="1"/>
+          <p:nvPr/>
+        </p:nvSpPr>
+        <p:spPr>
+          <a:xfrm>
+            <a:off x="731520" y="457200"/>
+            <a:ext cx="10728655" cy="1005840"/>
+          </a:xfrm>
+          <a:prstGeom prst="rect">
+            <a:avLst/>
+          </a:prstGeom>
+          <a:noFill/>
+        </p:spPr>
+        <p:txBody>
+          <a:bodyPr wrap="square">
+            <a:spAutoFit/>
+          </a:bodyPr>
+          <a:lstStyle/>
+          <a:p>
+            <a:pPr>
+              <a:defRPr sz="1100" b="1">
+                <a:solidFill>
+                  <a:srgbClr val="06B6D4"/>
+                </a:solidFill>
+              </a:defRPr>
+            </a:pPr>
+            <a:r>
+              <a:t>WEB APPLICATION INTERFACE • PORT 5010</a:t>
+            </a:r>
+          </a:p>
+          <a:p>
+            <a:pPr>
+              <a:defRPr sz="2200" b="1">
+                <a:solidFill>
+                  <a:srgbClr val="F8FAFC"/>
+                </a:solidFill>
+              </a:defRPr>
+            </a:pPr>
+            <a:r>
+              <a:t>Executive Forensics Dashboard &amp; Laboratory Telemetry</a:t>
+            </a:r>
+          </a:p>
+        </p:txBody>
+      </p:sp>
+      <p:pic>
+        <p:nvPicPr>
+          <p:cNvPr id="4" name="Picture 3" descr="01_executive_dashboard.png"/>
+          <p:cNvPicPr>
+            <a:picLocks noChangeAspect="1"/>
+          </p:cNvPicPr>
+          <p:nvPr/>
+        </p:nvPicPr>
+        <p:blipFill>
+          <a:blip r:embed="rId2"/>
+          <a:stretch>
+            <a:fillRect/>
+          </a:stretch>
+        </p:blipFill>
+        <p:spPr>
+          <a:xfrm>
+            <a:off x="731520" y="1554480"/>
+            <a:ext cx="6858000" cy="4297680"/>
+          </a:xfrm>
+          <a:prstGeom prst="rect">
+            <a:avLst/>
+          </a:prstGeom>
+        </p:spPr>
+      </p:pic>
+      <p:sp>
+        <p:nvSpPr>
+          <p:cNvPr id="5" name="Rounded Rectangle 4"/>
+          <p:cNvSpPr/>
+          <p:nvPr/>
+        </p:nvSpPr>
+        <p:spPr>
+          <a:xfrm>
+            <a:off x="7863840" y="1554480"/>
+            <a:ext cx="3566160" cy="4297680"/>
+          </a:xfrm>
+          <a:prstGeom prst="roundRect">
+            <a:avLst/>
+          </a:prstGeom>
+          <a:solidFill>
+            <a:srgbClr val="0F1C30"/>
+          </a:solidFill>
+          <a:ln w="19050">
+            <a:solidFill>
+              <a:srgbClr val="06B6D4"/>
+            </a:solidFill>
+          </a:ln>
+        </p:spPr>
+        <p:style>
+          <a:lnRef idx="1">
+            <a:schemeClr val="accent1"/>
+          </a:lnRef>
+          <a:fillRef idx="3">
+            <a:schemeClr val="accent1"/>
+          </a:fillRef>
+          <a:effectRef idx="2">
+            <a:schemeClr val="accent1"/>
+          </a:effectRef>
+          <a:fontRef idx="minor">
+            <a:schemeClr val="lt1"/>
+          </a:fontRef>
+        </p:style>
+        <p:txBody>
+          <a:bodyPr rtlCol="0" anchor="ctr"/>
+          <a:lstStyle/>
+          <a:p>
+            <a:pPr algn="ctr"/>
+          </a:p>
+        </p:txBody>
+      </p:sp>
+      <p:sp>
+        <p:nvSpPr>
+          <p:cNvPr id="6" name="TextBox 5"/>
+          <p:cNvSpPr txBox="1"/>
+          <p:nvPr/>
+        </p:nvSpPr>
+        <p:spPr>
+          <a:xfrm>
+            <a:off x="8046720" y="1737360"/>
+            <a:ext cx="3200400" cy="3931920"/>
+          </a:xfrm>
+          <a:prstGeom prst="rect">
+            <a:avLst/>
+          </a:prstGeom>
+          <a:noFill/>
+        </p:spPr>
+        <p:txBody>
+          <a:bodyPr wrap="square">
+            <a:spAutoFit/>
+          </a:bodyPr>
+          <a:lstStyle/>
+          <a:p>
+            <a:pPr>
+              <a:defRPr sz="1300" b="1">
+                <a:solidFill>
+                  <a:srgbClr val="06B6D4"/>
+                </a:solidFill>
+              </a:defRPr>
+            </a:pPr>
+            <a:r>
+              <a:t>REAL-TIME BIOMETRIC OVERSIGHT</a:t>
+            </a:r>
+          </a:p>
+          <a:p>
+            <a:pPr>
+              <a:defRPr sz="1100">
+                <a:solidFill>
+                  <a:srgbClr val="F8FAFC"/>
+                </a:solidFill>
+              </a:defRPr>
+            </a:pPr>
+            <a:r>
+              <a:t>The Executive Dashboard surfaces key security indicators:</a:t>
+            </a:r>
+            <a:br/>
+            <a:br/>
+            <a:r>
+              <a:t>• Total Audited Scans: 1,020+ biometric checks monitored.</a:t>
+            </a:r>
+            <a:br/>
+            <a:r>
+              <a:t>• Deepfakes Intercepted: 511 synthetic attacks neutralized.</a:t>
+            </a:r>
+            <a:br/>
+            <a:r>
+              <a:t>• Authentic Verification Rate: 49.9% cleared for biometric access.</a:t>
+            </a:r>
+            <a:br/>
+            <a:r>
+              <a:t>• MesoInception Accuracy: 99.5% with 0.999 ROC-AUC.</a:t>
+            </a:r>
+            <a:br/>
+            <a:r>
+              <a:t>• Forensics Engine Status: Live heartbeat monitoring on dedicated Port 5010.</a:t>
             </a:r>
           </a:p>
         </p:txBody>

</xml_diff>